<commit_message>
Layout pelas fotos: esteiras lado a lado, transferência a cada 4 estações, alto giro atrás do operador
- transferência com rolete direcionador (2 estações à esquerda, 2 à direita; ponta 3/26)
- bacia volta à esteira de transporte de qualquer ponto da estação
- prateleiras alinhadas, caixa do endereço pelo tipo; 015 abre o lado direito do corredor
- 4 displays E+Q nos andares 4-5 (orçamento, documento e apresentação atualizados)
- bacia verde e operador com uniforme verde, calça e sapato pretos

Co-Authored-By: Claude Opus 5.5 <noreply@anthropic.com>
Claude-Session: https://claude.ai/code/session_01TBWA3G7ku1j3oTf4VMkLud
</commit_message>
<xml_diff>
--- a/projeto/entregaveis/Apresentacao_PTL.pptx
+++ b/projeto/entregaveis/Apresentacao_PTL.pptx
@@ -127,7 +127,7 @@
   <p:extLst>
     <p:ext uri="{521415D9-36F7-43E2-AB2F-B90AF26B5E84}">
       <p14:sectionLst xmlns:p14="http://schemas.microsoft.com/office/powerpoint/2010/main">
-        <p14:section name="Abertura" id="{b2d9b1f1-22fa-bde3-f8b2-0adac9096441}">
+        <p14:section name="Abertura" id="{21b622cd-559b-16c0-3bc3-0f1ea520c719}">
           <p14:sldIdLst>
             <p14:sldId id="256"/>
             <p14:sldId id="257"/>
@@ -135,7 +135,7 @@
             <p14:sldId id="259"/>
           </p14:sldIdLst>
         </p14:section>
-        <p14:section name="Arquiteturas" id="{4645df77-651a-c04a-d833-d6c909fd6b99}">
+        <p14:section name="Arquiteturas" id="{8fe82bec-6a1a-ebf0-ed7f-99891ddcd189}">
           <p14:sldIdLst>
             <p14:sldId id="260"/>
             <p14:sldId id="261"/>
@@ -143,7 +143,7 @@
             <p14:sldId id="263"/>
           </p14:sldIdLst>
         </p14:section>
-        <p14:section name="A estação" id="{64617fa1-d537-cf73-62b1-e35a6f49e71a}">
+        <p14:section name="A estação" id="{a47bcbd5-cc95-b6ab-270e-29db21cb77e2}">
           <p14:sldIdLst>
             <p14:sldId id="264"/>
             <p14:sldId id="265"/>
@@ -153,14 +153,14 @@
             <p14:sldId id="269"/>
           </p14:sldIdLst>
         </p14:section>
-        <p14:section name="Orçamento" id="{6c7c98f7-b4dc-df81-8f8d-eee63744bfa8}">
+        <p14:section name="Orçamento" id="{98810e4d-940d-2222-90bb-de06af1ad29d}">
           <p14:sldIdLst>
             <p14:sldId id="270"/>
             <p14:sldId id="271"/>
             <p14:sldId id="272"/>
           </p14:sldIdLst>
         </p14:section>
-        <p14:section name="Próximos passos" id="{9b78558b-3e05-b09e-a027-6858d88e72a8}">
+        <p14:section name="Próximos passos" id="{1bffa95f-2526-a345-a749-8f153bc31690}">
           <p14:sldIdLst>
             <p14:sldId id="273"/>
             <p14:sldId id="274"/>
@@ -298,22 +298,22 @@
                 <c:formatCode>General</c:formatCode>
                 <c:ptCount val="6"/>
                 <c:pt idx="0">
-                  <c:v>187</c:v>
+                  <c:v>199</c:v>
                 </c:pt>
                 <c:pt idx="1">
-                  <c:v>255</c:v>
+                  <c:v>270</c:v>
                 </c:pt>
                 <c:pt idx="2">
-                  <c:v>278</c:v>
+                  <c:v>293</c:v>
                 </c:pt>
                 <c:pt idx="3">
-                  <c:v>279</c:v>
+                  <c:v>294</c:v>
                 </c:pt>
                 <c:pt idx="4">
-                  <c:v>326</c:v>
+                  <c:v>348</c:v>
                 </c:pt>
                 <c:pt idx="5">
-                  <c:v>796</c:v>
+                  <c:v>852</c:v>
                 </c:pt>
               </c:numCache>
             </c:numRef>
@@ -947,7 +947,7 @@
           <a:p>
             <a:r>
               <a:rPr lang="en-US" dirty="0"/>
-              <a:t>Planta conforme o desenho enviado pela operação. Lado esquerdo do corredor: prédios 020-031; lado direito: 032 até o último; prédio 015 (150-153) na cabeceira. Os blocos do baixo giro são de costas entre estações vizinhas. Medidas a confirmar com as fotos.</a:t>
+              <a:t>Esteira de transporte e de separação lado a lado (≈ 20 cm). A transferência passa a bacia para a separação e o rolete direcionador manda para 2 estações à esquerda ou 2 à direita (ex.: entre 11 e 12 atende 10 a 13; na ponta, entre 3 e 4 atende 3, 4 e 5). A bacia só entra nas estações com itens do pedido. Alto giro atrás do operador; corredor do baixo giro com 020-031 à esquerda e 015 + 043 a 032 à direita.</a:t>
             </a:r>
             <a:endParaRPr lang="en-US" dirty="0"/>
           </a:p>
@@ -1035,7 +1035,7 @@
           <a:p>
             <a:r>
               <a:rPr lang="en-US" dirty="0"/>
-              <a:t>A altura de cada endereço depende de quantos endereços o prédio tem. Estação 05: 209 endereços. 49 de alto giro (29 com display próprio + 20 nos blocos dos andares 4-5) e 160 de baixo giro em 6 zonas. O tamanho da zona é parâmetro e será ajustado no piloto.</a:t>
+              <a:t>Prateleiras alinhadas; a caixa do endereço muda de tamanho pelo tipo. Estação 05: 209 endereços. 49 de alto giro (29 com display próprio + 20 nos andares 4-5, atendidos por 4 displays E+Q) e 160 de baixo giro em 6 zonas. O tamanho da zona é parâmetro e será ajustado no piloto.</a:t>
             </a:r>
             <a:endParaRPr lang="en-US" dirty="0"/>
           </a:p>
@@ -1563,7 +1563,7 @@
           <a:p>
             <a:r>
               <a:rPr lang="en-US" dirty="0"/>
-              <a:t>Valores com instalação. 12 V × 5 V: o custo de peças fica praticamente igual (R$ 187 mil × R$ 186 mil), mas 5 V exige mais pontos de alimentação e aumenta a manutenção — por isso a recomendação é 12 V.</a:t>
+              <a:t>Valores com instalação. 12 V × 5 V: o custo de peças fica praticamente igual (R$ 199 mil × R$ 197 mil), mas 5 V exige mais pontos de alimentação e aumenta a manutenção — por isso a recomendação é 12 V.</a:t>
             </a:r>
             <a:endParaRPr lang="en-US" dirty="0"/>
           </a:p>
@@ -3928,7 +3928,7 @@
                   <a:schemeClr val="tx1"/>
                 </a:solidFill>
               </a:rPr>
-              <a:t>A bacia entra pela transferência, é separada e volta à esteira</a:t>
+              <a:t>Uma transferência atende 4 estações; a bacia volta à esteira de qualquer ponto</a:t>
             </a:r>
             <a:endParaRPr lang="en-US" sz="2600" dirty="0"/>
           </a:p>
@@ -3950,8 +3950,8 @@
         </p:blipFill>
         <p:spPr>
           <a:xfrm>
-            <a:off x="1280160" y="1143000"/>
-            <a:ext cx="9601200" cy="5120640"/>
+            <a:off x="1027497" y="1143000"/>
+            <a:ext cx="10106526" cy="5120640"/>
           </a:xfrm>
           <a:prstGeom prst="rect">
             <a:avLst/>
@@ -4060,7 +4060,7 @@
                   <a:schemeClr val="tx1"/>
                 </a:solidFill>
               </a:rPr>
-              <a:t>Andar 0 em cima; cada endereço de alto giro tem display e o baixo giro usa zonas</a:t>
+              <a:t>Andar 0 em cima; alto giro com display por endereço e baixo giro por zonas</a:t>
             </a:r>
             <a:endParaRPr lang="en-US" sz="2600" dirty="0"/>
           </a:p>
@@ -4082,8 +4082,8 @@
         </p:blipFill>
         <p:spPr>
           <a:xfrm>
-            <a:off x="457200" y="1280160"/>
-            <a:ext cx="11247120" cy="3749040"/>
+            <a:off x="492760" y="1280160"/>
+            <a:ext cx="11176000" cy="4023360"/>
           </a:xfrm>
           <a:prstGeom prst="rect">
             <a:avLst/>
@@ -4228,7 +4228,7 @@
                   <a:schemeClr val="accent6"/>
                 </a:solidFill>
               </a:rPr>
-              <a:t>2 blocos por estação (esq./dir.) com endereço + quantidade</a:t>
+              <a:t>4 displays por estação (A4 e A5 em cada lado) com endereço + quantidade</a:t>
             </a:r>
             <a:endParaRPr lang="en-US" sz="1200" dirty="0"/>
           </a:p>
@@ -6197,7 +6197,7 @@
                             <a:schemeClr val="tx2"/>
                           </a:solidFill>
                         </a:rPr>
-                        <a:t>10.443</a:t>
+                        <a:t>10.994</a:t>
                       </a:r>
                       <a:endParaRPr lang="en-US" sz="1300" dirty="0"/>
                     </a:p>
@@ -6315,7 +6315,7 @@
                             <a:schemeClr val="tx2"/>
                           </a:solidFill>
                         </a:rPr>
-                        <a:t>13.875</a:t>
+                        <a:t>14.566</a:t>
                       </a:r>
                       <a:endParaRPr lang="en-US" sz="1300" dirty="0"/>
                     </a:p>
@@ -6433,7 +6433,7 @@
                             <a:schemeClr val="tx2"/>
                           </a:solidFill>
                         </a:rPr>
-                        <a:t>15.048</a:t>
+                        <a:t>15.738</a:t>
                       </a:r>
                       <a:endParaRPr lang="en-US" sz="1300" dirty="0"/>
                     </a:p>
@@ -6551,7 +6551,7 @@
                             <a:schemeClr val="tx2"/>
                           </a:solidFill>
                         </a:rPr>
-                        <a:t>31.822</a:t>
+                        <a:t>32.808</a:t>
                       </a:r>
                       <a:endParaRPr lang="en-US" sz="1300" dirty="0"/>
                     </a:p>
@@ -6669,7 +6669,7 @@
                             <a:schemeClr val="tx2"/>
                           </a:solidFill>
                         </a:rPr>
-                        <a:t>40.650</a:t>
+                        <a:t>43.196</a:t>
                       </a:r>
                       <a:endParaRPr lang="en-US" sz="1300" dirty="0"/>
                     </a:p>
@@ -6987,7 +6987,7 @@
                   <a:schemeClr val="accent2"/>
                 </a:solidFill>
               </a:rPr>
-              <a:t>R$ 255 mil</a:t>
+              <a:t>R$ 270 mil</a:t>
             </a:r>
             <a:endParaRPr lang="en-US" sz="3000" dirty="0"/>
           </a:p>
@@ -7248,7 +7248,7 @@
                   <a:schemeClr val="accent3"/>
                 </a:solidFill>
               </a:rPr>
-              <a:t>R$ 326 mil</a:t>
+              <a:t>R$ 348 mil</a:t>
             </a:r>
             <a:endParaRPr lang="en-US" sz="3000" dirty="0"/>
           </a:p>
@@ -7509,7 +7509,7 @@
                   <a:schemeClr val="accent5"/>
                 </a:solidFill>
               </a:rPr>
-              <a:t>R$ 796 mil</a:t>
+              <a:t>R$ 852 mil</a:t>
             </a:r>
             <a:endParaRPr lang="en-US" sz="3000" dirty="0"/>
           </a:p>
@@ -9793,7 +9793,7 @@
                   <a:schemeClr val="tx1"/>
                 </a:solidFill>
               </a:rPr>
-              <a:t>Resumo: piloto de R$ 13,9 mil para validar a operação completa</a:t>
+              <a:t>Resumo: piloto de R$ 14,6 mil para validar a operação completa</a:t>
             </a:r>
             <a:endParaRPr lang="en-US" sz="2600" dirty="0"/>
           </a:p>
@@ -10135,7 +10135,7 @@
                 <a:ea typeface="Arial" pitchFamily="34" charset="-122"/>
                 <a:cs typeface="Arial" pitchFamily="34" charset="-120"/>
               </a:rPr>
-              <a:t>R$ 255 mil</a:t>
+              <a:t>R$ 270 mil</a:t>
             </a:r>
             <a:endParaRPr lang="en-US" sz="3000" dirty="0"/>
           </a:p>
@@ -10273,7 +10273,7 @@
                 <a:ea typeface="Arial" pitchFamily="34" charset="-122"/>
                 <a:cs typeface="Arial" pitchFamily="34" charset="-120"/>
               </a:rPr>
-              <a:t>R$ 13,9 mil</a:t>
+              <a:t>R$ 14,6 mil</a:t>
             </a:r>
             <a:endParaRPr lang="en-US" sz="3000" dirty="0"/>
           </a:p>
@@ -10979,7 +10979,7 @@
                   <a:srgbClr val="C9D3E0"/>
                 </a:solidFill>
               </a:rPr>
-              <a:t>1. Aprovar o piloto nas estações 05 e 27 (≈ R$ 13,9 mil)</a:t>
+              <a:t>1. Aprovar o piloto nas estações 05 e 27 (≈ R$ 14,6 mil)</a:t>
             </a:r>
             <a:endParaRPr lang="en-US" sz="2000" dirty="0"/>
           </a:p>
@@ -14200,7 +14200,7 @@
                             <a:schemeClr val="tx2"/>
                           </a:solidFill>
                         </a:rPr>
-                        <a:t>R$ 255 mil</a:t>
+                        <a:t>R$ 270 mil</a:t>
                       </a:r>
                       <a:endParaRPr lang="en-US" sz="1500" dirty="0"/>
                     </a:p>
@@ -14258,7 +14258,7 @@
                             <a:schemeClr val="tx2"/>
                           </a:solidFill>
                         </a:rPr>
-                        <a:t>R$ 278 mil</a:t>
+                        <a:t>R$ 293 mil</a:t>
                       </a:r>
                       <a:endParaRPr lang="en-US" sz="1500" dirty="0"/>
                     </a:p>

</xml_diff>

<commit_message>
Alto giro na frente do operador com as esteiras passando por dentro
- esteira de separação e de transporte por baixo do andar 3 e por cima do andar 4
- corredor do baixo giro atrás do operador
- planta, elevações, documento técnico e apresentação atualizados

Co-Authored-By: Claude Opus 5.5 <noreply@anthropic.com>
Claude-Session: https://claude.ai/code/session_01TBWA3G7ku1j3oTf4VMkLud
</commit_message>
<xml_diff>
--- a/projeto/entregaveis/Apresentacao_PTL.pptx
+++ b/projeto/entregaveis/Apresentacao_PTL.pptx
@@ -127,7 +127,7 @@
   <p:extLst>
     <p:ext uri="{521415D9-36F7-43E2-AB2F-B90AF26B5E84}">
       <p14:sectionLst xmlns:p14="http://schemas.microsoft.com/office/powerpoint/2010/main">
-        <p14:section name="Abertura" id="{21b622cd-559b-16c0-3bc3-0f1ea520c719}">
+        <p14:section name="Abertura" id="{5f1fa104-00d3-1685-0bc9-d1fbdc19b617}">
           <p14:sldIdLst>
             <p14:sldId id="256"/>
             <p14:sldId id="257"/>
@@ -135,7 +135,7 @@
             <p14:sldId id="259"/>
           </p14:sldIdLst>
         </p14:section>
-        <p14:section name="Arquiteturas" id="{8fe82bec-6a1a-ebf0-ed7f-99891ddcd189}">
+        <p14:section name="Arquiteturas" id="{8b197640-b7b4-57ef-7746-b5fb3f907cf7}">
           <p14:sldIdLst>
             <p14:sldId id="260"/>
             <p14:sldId id="261"/>
@@ -143,7 +143,7 @@
             <p14:sldId id="263"/>
           </p14:sldIdLst>
         </p14:section>
-        <p14:section name="A estação" id="{a47bcbd5-cc95-b6ab-270e-29db21cb77e2}">
+        <p14:section name="A estação" id="{cf2b71bc-71b8-ee8a-4a20-199045a29033}">
           <p14:sldIdLst>
             <p14:sldId id="264"/>
             <p14:sldId id="265"/>
@@ -153,14 +153,14 @@
             <p14:sldId id="269"/>
           </p14:sldIdLst>
         </p14:section>
-        <p14:section name="Orçamento" id="{98810e4d-940d-2222-90bb-de06af1ad29d}">
+        <p14:section name="Orçamento" id="{81903010-aa68-004f-009e-6fbe50acc327}">
           <p14:sldIdLst>
             <p14:sldId id="270"/>
             <p14:sldId id="271"/>
             <p14:sldId id="272"/>
           </p14:sldIdLst>
         </p14:section>
-        <p14:section name="Próximos passos" id="{1bffa95f-2526-a345-a749-8f153bc31690}">
+        <p14:section name="Próximos passos" id="{54aae9eb-4a0a-8f1c-7a4b-ae3468b75c27}">
           <p14:sldIdLst>
             <p14:sldId id="273"/>
             <p14:sldId id="274"/>
@@ -947,7 +947,7 @@
           <a:p>
             <a:r>
               <a:rPr lang="en-US" dirty="0"/>
-              <a:t>Esteira de transporte e de separação lado a lado (≈ 20 cm). A transferência passa a bacia para a separação e o rolete direcionador manda para 2 estações à esquerda ou 2 à direita (ex.: entre 11 e 12 atende 10 a 13; na ponta, entre 3 e 4 atende 3, 4 e 5). A bacia só entra nas estações com itens do pedido. Alto giro atrás do operador; corredor do baixo giro com 020-031 à esquerda e 015 + 043 a 032 à direita.</a:t>
+              <a:t>Esteira de transporte e de separação lado a lado (≈ 20 cm). A transferência passa a bacia para a separação e o rolete direcionador manda para 2 estações à esquerda ou 2 à direita (ex.: entre 11 e 12 atende 10 a 13; na ponta, entre 3 e 4 atende 3, 4 e 5). A bacia só entra nas estações com itens do pedido. Alto giro na frente do operador, com as esteiras passando por dentro (por baixo do andar 3 e por cima do andar 4); corredor do baixo giro atrás do operador, com 020-031 à esquerda e 015 + 043 a 032 à direita.</a:t>
             </a:r>
             <a:endParaRPr lang="en-US" dirty="0"/>
           </a:p>

</xml_diff>

<commit_message>
Separação aberta na frente, 4 zonas por lado no baixo giro com displays na altura dos olhos
- esteira de transporte por dentro do alto giro; separação na frente, aberta
- baixo giro: 4 zonas por lado (E1-E4, D1-D4), display E+Q a ~1,5 m; profundidade ~2 m
- caixas de endereço menores
- orçamento, diagramas, documento e apresentação atualizados

Co-Authored-By: Claude Opus 5.5 <noreply@anthropic.com>
Claude-Session: https://claude.ai/code/session_01TBWA3G7ku1j3oTf4VMkLud
</commit_message>
<xml_diff>
--- a/projeto/entregaveis/Apresentacao_PTL.pptx
+++ b/projeto/entregaveis/Apresentacao_PTL.pptx
@@ -127,7 +127,7 @@
   <p:extLst>
     <p:ext uri="{521415D9-36F7-43E2-AB2F-B90AF26B5E84}">
       <p14:sectionLst xmlns:p14="http://schemas.microsoft.com/office/powerpoint/2010/main">
-        <p14:section name="Abertura" id="{5f1fa104-00d3-1685-0bc9-d1fbdc19b617}">
+        <p14:section name="Abertura" id="{c31dbac4-77b0-3de3-7d39-04559b4fc34a}">
           <p14:sldIdLst>
             <p14:sldId id="256"/>
             <p14:sldId id="257"/>
@@ -135,7 +135,7 @@
             <p14:sldId id="259"/>
           </p14:sldIdLst>
         </p14:section>
-        <p14:section name="Arquiteturas" id="{8b197640-b7b4-57ef-7746-b5fb3f907cf7}">
+        <p14:section name="Arquiteturas" id="{4722a07c-d92f-8b07-dc3e-caa3fea251fe}">
           <p14:sldIdLst>
             <p14:sldId id="260"/>
             <p14:sldId id="261"/>
@@ -143,7 +143,7 @@
             <p14:sldId id="263"/>
           </p14:sldIdLst>
         </p14:section>
-        <p14:section name="A estação" id="{cf2b71bc-71b8-ee8a-4a20-199045a29033}">
+        <p14:section name="A estação" id="{c8ccc2e1-f1ca-33f6-7220-09f3c7f51cb9}">
           <p14:sldIdLst>
             <p14:sldId id="264"/>
             <p14:sldId id="265"/>
@@ -153,14 +153,14 @@
             <p14:sldId id="269"/>
           </p14:sldIdLst>
         </p14:section>
-        <p14:section name="Orçamento" id="{81903010-aa68-004f-009e-6fbe50acc327}">
+        <p14:section name="Orçamento" id="{6c1d7855-4790-9399-ac10-5e87b7498320}">
           <p14:sldIdLst>
             <p14:sldId id="270"/>
             <p14:sldId id="271"/>
             <p14:sldId id="272"/>
           </p14:sldIdLst>
         </p14:section>
-        <p14:section name="Próximos passos" id="{54aae9eb-4a0a-8f1c-7a4b-ae3468b75c27}">
+        <p14:section name="Próximos passos" id="{50796829-a88e-d4d8-327a-13f8cc740379}">
           <p14:sldIdLst>
             <p14:sldId id="273"/>
             <p14:sldId id="274"/>
@@ -298,22 +298,22 @@
                 <c:formatCode>General</c:formatCode>
                 <c:ptCount val="6"/>
                 <c:pt idx="0">
-                  <c:v>199</c:v>
+                  <c:v>211</c:v>
                 </c:pt>
                 <c:pt idx="1">
-                  <c:v>270</c:v>
+                  <c:v>284</c:v>
                 </c:pt>
                 <c:pt idx="2">
-                  <c:v>293</c:v>
+                  <c:v>308</c:v>
                 </c:pt>
                 <c:pt idx="3">
-                  <c:v>294</c:v>
+                  <c:v>309</c:v>
                 </c:pt>
                 <c:pt idx="4">
-                  <c:v>348</c:v>
+                  <c:v>369</c:v>
                 </c:pt>
                 <c:pt idx="5">
-                  <c:v>852</c:v>
+                  <c:v>906</c:v>
                 </c:pt>
               </c:numCache>
             </c:numRef>
@@ -947,7 +947,7 @@
           <a:p>
             <a:r>
               <a:rPr lang="en-US" dirty="0"/>
-              <a:t>Esteira de transporte e de separação lado a lado (≈ 20 cm). A transferência passa a bacia para a separação e o rolete direcionador manda para 2 estações à esquerda ou 2 à direita (ex.: entre 11 e 12 atende 10 a 13; na ponta, entre 3 e 4 atende 3, 4 e 5). A bacia só entra nas estações com itens do pedido. Alto giro na frente do operador, com as esteiras passando por dentro (por baixo do andar 3 e por cima do andar 4); corredor do baixo giro atrás do operador, com 020-031 à esquerda e 015 + 043 a 032 à direita.</a:t>
+              <a:t>Esteira de transporte e de separação lado a lado (≈ 20 cm). A transferência passa a bacia para a separação e o rolete direcionador manda para 2 estações à esquerda ou 2 à direita (ex.: entre 11 e 12 atende 10 a 13; na ponta, entre 3 e 4 atende 3, 4 e 5). A bacia só entra nas estações com itens do pedido. Alto giro na frente do operador, com a esteira de transporte passando por dentro (por baixo do andar 3 e por cima do andar 4) e a de separação aberta na frente; corredor do baixo giro atrás do operador, com 020-031 à esquerda e 015 + 043 a 032 à direita.</a:t>
             </a:r>
             <a:endParaRPr lang="en-US" dirty="0"/>
           </a:p>
@@ -1035,7 +1035,7 @@
           <a:p>
             <a:r>
               <a:rPr lang="en-US" dirty="0"/>
-              <a:t>Prateleiras alinhadas; a caixa do endereço muda de tamanho pelo tipo. Estação 05: 209 endereços. 49 de alto giro (29 com display próprio + 20 nos andares 4-5, atendidos por 4 displays E+Q) e 160 de baixo giro em 6 zonas. O tamanho da zona é parâmetro e será ajustado no piloto.</a:t>
+              <a:t>Prateleiras alinhadas; a caixa do endereço muda de tamanho pelo tipo. Estação 05: 209 endereços. 49 de alto giro (29 com display próprio + 20 nos andares 4-5, atendidos por 4 displays E+Q) e 160 de baixo giro em 8 zonas (4 por lado, displays na altura dos olhos). O tamanho da zona é parâmetro e será ajustado no piloto.</a:t>
             </a:r>
             <a:endParaRPr lang="en-US" dirty="0"/>
           </a:p>
@@ -1563,7 +1563,7 @@
           <a:p>
             <a:r>
               <a:rPr lang="en-US" dirty="0"/>
-              <a:t>Valores com instalação. 12 V × 5 V: o custo de peças fica praticamente igual (R$ 199 mil × R$ 197 mil), mas 5 V exige mais pontos de alimentação e aumenta a manutenção — por isso a recomendação é 12 V.</a:t>
+              <a:t>Valores com instalação. 12 V × 5 V: o custo de peças fica praticamente igual (R$ 211 mil × R$ 208 mil), mas 5 V exige mais pontos de alimentação e aumenta a manutenção — por isso a recomendação é 12 V.</a:t>
             </a:r>
             <a:endParaRPr lang="en-US" dirty="0"/>
           </a:p>
@@ -4300,7 +4300,7 @@
                   <a:schemeClr val="accent6"/>
                 </a:solidFill>
               </a:rPr>
-              <a:t>1 display de endereço + quantidade a cada 4 prédios (6 a 9 zonas)</a:t>
+              <a:t>4 zonas por lado do corredor, display de endereço + quantidade na altura dos olhos</a:t>
             </a:r>
             <a:endParaRPr lang="en-US" sz="1200" dirty="0"/>
           </a:p>
@@ -6197,7 +6197,7 @@
                             <a:schemeClr val="tx2"/>
                           </a:solidFill>
                         </a:rPr>
-                        <a:t>10.994</a:t>
+                        <a:t>11.668</a:t>
                       </a:r>
                       <a:endParaRPr lang="en-US" sz="1300" dirty="0"/>
                     </a:p>
@@ -6315,7 +6315,7 @@
                             <a:schemeClr val="tx2"/>
                           </a:solidFill>
                         </a:rPr>
-                        <a:t>14.566</a:t>
+                        <a:t>15.415</a:t>
                       </a:r>
                       <a:endParaRPr lang="en-US" sz="1300" dirty="0"/>
                     </a:p>
@@ -6433,7 +6433,7 @@
                             <a:schemeClr val="tx2"/>
                           </a:solidFill>
                         </a:rPr>
-                        <a:t>15.738</a:t>
+                        <a:t>16.588</a:t>
                       </a:r>
                       <a:endParaRPr lang="en-US" sz="1300" dirty="0"/>
                     </a:p>
@@ -6551,7 +6551,7 @@
                             <a:schemeClr val="tx2"/>
                           </a:solidFill>
                         </a:rPr>
-                        <a:t>32.808</a:t>
+                        <a:t>34.027</a:t>
                       </a:r>
                       <a:endParaRPr lang="en-US" sz="1300" dirty="0"/>
                     </a:p>
@@ -6669,7 +6669,7 @@
                             <a:schemeClr val="tx2"/>
                           </a:solidFill>
                         </a:rPr>
-                        <a:t>43.196</a:t>
+                        <a:t>46.363</a:t>
                       </a:r>
                       <a:endParaRPr lang="en-US" sz="1300" dirty="0"/>
                     </a:p>
@@ -6987,7 +6987,7 @@
                   <a:schemeClr val="accent2"/>
                 </a:solidFill>
               </a:rPr>
-              <a:t>R$ 270 mil</a:t>
+              <a:t>R$ 284 mil</a:t>
             </a:r>
             <a:endParaRPr lang="en-US" sz="3000" dirty="0"/>
           </a:p>
@@ -7248,7 +7248,7 @@
                   <a:schemeClr val="accent3"/>
                 </a:solidFill>
               </a:rPr>
-              <a:t>R$ 348 mil</a:t>
+              <a:t>R$ 369 mil</a:t>
             </a:r>
             <a:endParaRPr lang="en-US" sz="3000" dirty="0"/>
           </a:p>
@@ -7509,7 +7509,7 @@
                   <a:schemeClr val="accent5"/>
                 </a:solidFill>
               </a:rPr>
-              <a:t>R$ 852 mil</a:t>
+              <a:t>R$ 906 mil</a:t>
             </a:r>
             <a:endParaRPr lang="en-US" sz="3000" dirty="0"/>
           </a:p>
@@ -9793,7 +9793,7 @@
                   <a:schemeClr val="tx1"/>
                 </a:solidFill>
               </a:rPr>
-              <a:t>Resumo: piloto de R$ 14,6 mil para validar a operação completa</a:t>
+              <a:t>Resumo: piloto de R$ 15,4 mil para validar a operação completa</a:t>
             </a:r>
             <a:endParaRPr lang="en-US" sz="2600" dirty="0"/>
           </a:p>
@@ -10135,7 +10135,7 @@
                 <a:ea typeface="Arial" pitchFamily="34" charset="-122"/>
                 <a:cs typeface="Arial" pitchFamily="34" charset="-120"/>
               </a:rPr>
-              <a:t>R$ 270 mil</a:t>
+              <a:t>R$ 284 mil</a:t>
             </a:r>
             <a:endParaRPr lang="en-US" sz="3000" dirty="0"/>
           </a:p>
@@ -10273,7 +10273,7 @@
                 <a:ea typeface="Arial" pitchFamily="34" charset="-122"/>
                 <a:cs typeface="Arial" pitchFamily="34" charset="-120"/>
               </a:rPr>
-              <a:t>R$ 14,6 mil</a:t>
+              <a:t>R$ 15,4 mil</a:t>
             </a:r>
             <a:endParaRPr lang="en-US" sz="3000" dirty="0"/>
           </a:p>
@@ -10979,7 +10979,7 @@
                   <a:srgbClr val="C9D3E0"/>
                 </a:solidFill>
               </a:rPr>
-              <a:t>1. Aprovar o piloto nas estações 05 e 27 (≈ R$ 14,6 mil)</a:t>
+              <a:t>1. Aprovar o piloto nas estações 05 e 27 (≈ R$ 15,4 mil)</a:t>
             </a:r>
             <a:endParaRPr lang="en-US" sz="2000" dirty="0"/>
           </a:p>
@@ -14200,7 +14200,7 @@
                             <a:schemeClr val="tx2"/>
                           </a:solidFill>
                         </a:rPr>
-                        <a:t>R$ 270 mil</a:t>
+                        <a:t>R$ 284 mil</a:t>
                       </a:r>
                       <a:endParaRPr lang="en-US" sz="1500" dirty="0"/>
                     </a:p>
@@ -14258,7 +14258,7 @@
                             <a:schemeClr val="tx2"/>
                           </a:solidFill>
                         </a:rPr>
-                        <a:t>R$ 293 mil</a:t>
+                        <a:t>R$ 308 mil</a:t>
                       </a:r>
                       <a:endParaRPr lang="en-US" sz="1500" dirty="0"/>
                     </a:p>

</xml_diff>

<commit_message>
Revisa o orçamento completo do PTL
- Canaleta calculada pelo layout de cada estação (antes 24 m fixos)
- Barramento: 1 cabo por nó/E+Q + saídas do concentrador
- Itens que faltavam: alimentação e DPS do concentrador, tomadas novas,
  nobreak e mini rack dos switches, uplink, ferramentas e frete
- Botão metálico com anel de LED; instalação por quantidade com hora extra
- Treinamento de operadores e manutenção em todos os cenários
- B1 com 2 pulseiras por estação + carregador; B2 como nó do barramento
- T1 com montagem final dos módulos da EMS; cabo em cadeia de 1 m por Q
- Software a R$ 103,78/h (salário de mercado) + implantação do servidor
- Câmbio atualizado, contingência de 10% e investimento total no Resumo
- Documento (v1.2) e apresentação atualizados com os novos valores

Co-Authored-By: Claude Opus 5.5 <noreply@anthropic.com>
Claude-Session: https://claude.ai/code/session_01TBWA3G7ku1j3oTf4VMkLud
</commit_message>
<xml_diff>
--- a/projeto/entregaveis/Apresentacao_PTL.pptx
+++ b/projeto/entregaveis/Apresentacao_PTL.pptx
@@ -128,7 +128,7 @@
   <p:extLst>
     <p:ext uri="{521415D9-36F7-43E2-AB2F-B90AF26B5E84}">
       <p14:sectionLst xmlns:p14="http://schemas.microsoft.com/office/powerpoint/2010/main">
-        <p14:section name="Abertura" id="{278e3b4e-6e38-e05d-4960-ccadc24713f7}">
+        <p14:section name="Abertura" id="{9a205dbd-4fe7-90e7-257c-bfea786cf184}">
           <p14:sldIdLst>
             <p14:sldId id="256"/>
             <p14:sldId id="257"/>
@@ -136,7 +136,7 @@
             <p14:sldId id="259"/>
           </p14:sldIdLst>
         </p14:section>
-        <p14:section name="Arquiteturas" id="{ce70d762-c69b-e26e-f8e3-9e7301095ff9}">
+        <p14:section name="Arquiteturas" id="{ee748f59-f453-c202-f8cc-7133870ab634}">
           <p14:sldIdLst>
             <p14:sldId id="260"/>
             <p14:sldId id="261"/>
@@ -145,7 +145,7 @@
             <p14:sldId id="264"/>
           </p14:sldIdLst>
         </p14:section>
-        <p14:section name="A estação" id="{bbd3f541-f774-f9b1-d686-b4ad210f8063}">
+        <p14:section name="A estação" id="{3b7fb97d-3a79-a642-956b-4a3eda735223}">
           <p14:sldIdLst>
             <p14:sldId id="265"/>
             <p14:sldId id="266"/>
@@ -155,14 +155,14 @@
             <p14:sldId id="270"/>
           </p14:sldIdLst>
         </p14:section>
-        <p14:section name="Orçamento" id="{03d8e819-da12-c6e9-f4bc-084a033cb2ba}">
+        <p14:section name="Orçamento" id="{53912458-517c-0a55-f3d4-61c501c29c2e}">
           <p14:sldIdLst>
             <p14:sldId id="271"/>
             <p14:sldId id="272"/>
             <p14:sldId id="273"/>
           </p14:sldIdLst>
         </p14:section>
-        <p14:section name="Próximos passos" id="{38125a31-ca9d-c877-ddba-bb8e34f0b8d0}">
+        <p14:section name="Próximos passos" id="{5d1b2d9f-108d-d823-7a0b-5d50722e4f1b}">
           <p14:sldIdLst>
             <p14:sldId id="274"/>
             <p14:sldId id="275"/>
@@ -272,10 +272,10 @@
                 <c:ptCount val="6"/>
                 <c:lvl>
                   <c:pt idx="0">
-                    <c:v>A interna, só peças</c:v>
+                    <c:v>A interna, só materiais</c:v>
                   </c:pt>
                   <c:pt idx="1">
-                    <c:v>A interna, peças e mão de obra</c:v>
+                    <c:v>A interna, com mão de obra</c:v>
                   </c:pt>
                   <c:pt idx="2">
                     <c:v>B2, RFID com leitor fixo</c:v>
@@ -300,22 +300,22 @@
                 <c:formatCode>General</c:formatCode>
                 <c:ptCount val="6"/>
                 <c:pt idx="0">
-                  <c:v>211</c:v>
+                  <c:v>266</c:v>
                 </c:pt>
                 <c:pt idx="1">
-                  <c:v>284</c:v>
+                  <c:v>364</c:v>
                 </c:pt>
                 <c:pt idx="2">
-                  <c:v>308</c:v>
+                  <c:v>391</c:v>
                 </c:pt>
                 <c:pt idx="3">
-                  <c:v>309</c:v>
+                  <c:v>397</c:v>
                 </c:pt>
                 <c:pt idx="4">
-                  <c:v>369</c:v>
+                  <c:v>413</c:v>
                 </c:pt>
                 <c:pt idx="5">
-                  <c:v>906</c:v>
+                  <c:v>937</c:v>
                 </c:pt>
               </c:numCache>
             </c:numRef>
@@ -1565,7 +1565,7 @@
           <a:p>
             <a:r>
               <a:rPr lang="en-US" dirty="0"/>
-              <a:t>Fonte: Orcamento_PTL.xlsx. A placa própria só compensa em escala, por causa do projeto (cerca de R$ 15 mil) e da importação. Quantidades e preços podem ser alterados na planilha.</a:t>
+              <a:t>Fonte: Orcamento_PTL.xlsx. A placa própria só compensa em escala, por causa do projeto (cerca de R$ 15 mil) e da importação. Quantidades e preços podem ser alterados na planilha. Mão de obra a R$ 34,93/h (técnico) e software a R$ 103,78/h (analista de desenvolvimento), salários médios do salario.com.br com encargos. Os materiais incluem canaleta pelo layout real, alimentação dos concentradores, tomadas novas, nobreak e rack dos switches, ferramentas e frete.</a:t>
             </a:r>
             <a:endParaRPr lang="en-US" dirty="0"/>
           </a:p>
@@ -1653,7 +1653,7 @@
           <a:p>
             <a:r>
               <a:rPr lang="en-US" dirty="0"/>
-              <a:t>Valores com instalação. 12 V × 5 V: o custo de peças fica praticamente igual (R$ 211 mil × R$ 208 mil), mas o 5 V exige mais pontos de alimentação e aumenta a manutenção. Por isso a indicação é 12 V.</a:t>
+              <a:t>Valores com instalação. 12 V × 5 V: os materiais ficam praticamente iguais (R$ 266 mil × R$ 269 mil), porque o cabo de força extra do 5 V custa mais do que os reguladores economizados, e o 5 V ainda aumenta a manutenção. Por isso a indicação é 12 V.</a:t>
             </a:r>
             <a:endParaRPr lang="en-US" dirty="0"/>
           </a:p>
@@ -5780,7 +5780,7 @@
                   <a:srgbClr val="C9D3E0"/>
                 </a:solidFill>
               </a:rPr>
-              <a:t>Preços pesquisados em lojas brasileiras em 23/10/2026. Os itens estimados estão marcados na planilha.</a:t>
+              <a:t>Preços pesquisados em lojas brasileiras em 23 e 26/10/2026. Os itens estimados estão marcados na planilha.</a:t>
             </a:r>
             <a:endParaRPr lang="en-US" sz="1800" dirty="0"/>
           </a:p>
@@ -6075,7 +6075,7 @@
                             <a:schemeClr val="tx2"/>
                           </a:solidFill>
                         </a:rPr>
-                        <a:t>A interna, peças</a:t>
+                        <a:t>A interna, materiais</a:t>
                       </a:r>
                       <a:endParaRPr lang="en-US" sz="1300" dirty="0"/>
                     </a:p>
@@ -6133,7 +6133,7 @@
                             <a:schemeClr val="tx2"/>
                           </a:solidFill>
                         </a:rPr>
-                        <a:t>11.668</a:t>
+                        <a:t>16.707</a:t>
                       </a:r>
                       <a:endParaRPr lang="en-US" sz="1300" dirty="0"/>
                     </a:p>
@@ -6251,7 +6251,7 @@
                             <a:schemeClr val="tx2"/>
                           </a:solidFill>
                         </a:rPr>
-                        <a:t>15.415</a:t>
+                        <a:t>22.204</a:t>
                       </a:r>
                       <a:endParaRPr lang="en-US" sz="1300" dirty="0"/>
                     </a:p>
@@ -6369,7 +6369,7 @@
                             <a:schemeClr val="tx2"/>
                           </a:solidFill>
                         </a:rPr>
-                        <a:t>16.588</a:t>
+                        <a:t>23.542</a:t>
                       </a:r>
                       <a:endParaRPr lang="en-US" sz="1300" dirty="0"/>
                     </a:p>
@@ -6487,7 +6487,7 @@
                             <a:schemeClr val="tx2"/>
                           </a:solidFill>
                         </a:rPr>
-                        <a:t>34.027</a:t>
+                        <a:t>38.859</a:t>
                       </a:r>
                       <a:endParaRPr lang="en-US" sz="1300" dirty="0"/>
                     </a:p>
@@ -6605,7 +6605,7 @@
                             <a:schemeClr val="tx2"/>
                           </a:solidFill>
                         </a:rPr>
-                        <a:t>46.363</a:t>
+                        <a:t>50.447</a:t>
                       </a:r>
                       <a:endParaRPr lang="en-US" sz="1300" dirty="0"/>
                     </a:p>
@@ -6684,7 +6684,7 @@
                   <a:schemeClr val="accent6"/>
                 </a:solidFill>
               </a:rPr>
-              <a:t>Software interno estimado em cerca de 1.080 h (A) e 1.000 h (B). Mão de obra a R$ 34,93 por hora (salário médio de técnico com encargos).</a:t>
+              <a:t>Software interno: cerca de 1.104 h (A) e 1.024 h (B), ou R$ 115 mil e R$ 106 mil. Com 10% de contingência e o software, a Arquitetura A soma cerca de R$ 515 mil.</a:t>
             </a:r>
             <a:endParaRPr lang="en-US" sz="1200" dirty="0"/>
           </a:p>
@@ -6923,7 +6923,7 @@
                   <a:schemeClr val="accent2"/>
                 </a:solidFill>
               </a:rPr>
-              <a:t>R$ 284 mil</a:t>
+              <a:t>R$ 364 mil</a:t>
             </a:r>
             <a:endParaRPr lang="en-US" sz="3000" dirty="0"/>
           </a:p>
@@ -7184,7 +7184,7 @@
                   <a:schemeClr val="accent3"/>
                 </a:solidFill>
               </a:rPr>
-              <a:t>R$ 369 mil</a:t>
+              <a:t>R$ 413 mil</a:t>
             </a:r>
             <a:endParaRPr lang="en-US" sz="3000" dirty="0"/>
           </a:p>
@@ -7445,7 +7445,7 @@
                   <a:schemeClr val="accent5"/>
                 </a:solidFill>
               </a:rPr>
-              <a:t>R$ 906 mil</a:t>
+              <a:t>R$ 937 mil</a:t>
             </a:r>
             <a:endParaRPr lang="en-US" sz="3000" dirty="0"/>
           </a:p>
@@ -7539,7 +7539,7 @@
                   <a:schemeClr val="tx2"/>
                 </a:solidFill>
               </a:rPr>
-              <a:t>Cerca de três vezes o custo interno</a:t>
+              <a:t>Cerca de 2,5 vezes o custo interno</a:t>
             </a:r>
             <a:endParaRPr lang="en-US" sz="1400" dirty="0"/>
           </a:p>
@@ -9075,7 +9075,7 @@
                 <a:ea typeface="Arial" pitchFamily="34" charset="-122"/>
                 <a:cs typeface="Arial" pitchFamily="34" charset="-120"/>
               </a:rPr>
-              <a:t>R$ 284 mil</a:t>
+              <a:t>R$ 364 mil</a:t>
             </a:r>
             <a:endParaRPr lang="en-US" sz="3000" dirty="0"/>
           </a:p>
@@ -9213,7 +9213,7 @@
                 <a:ea typeface="Arial" pitchFamily="34" charset="-122"/>
                 <a:cs typeface="Arial" pitchFamily="34" charset="-120"/>
               </a:rPr>
-              <a:t>R$ 15,4 mil</a:t>
+              <a:t>R$ 22,2 mil</a:t>
             </a:r>
             <a:endParaRPr lang="en-US" sz="3000" dirty="0"/>
           </a:p>
@@ -10866,7 +10866,7 @@
                   <a:srgbClr val="C9D3E0"/>
                 </a:solidFill>
               </a:rPr>
-              <a:t>1. Aprovar o piloto nas estações 05 e 27 (cerca de R$ 15,4 mil)</a:t>
+              <a:t>1. Aprovar o piloto nas estações 05 e 27 (cerca de R$ 22 mil)</a:t>
             </a:r>
             <a:endParaRPr lang="en-US" sz="2000" dirty="0"/>
           </a:p>
@@ -14219,7 +14219,7 @@
                             <a:schemeClr val="tx2"/>
                           </a:solidFill>
                         </a:rPr>
-                        <a:t>R$ 284 mil</a:t>
+                        <a:t>R$ 364 mil</a:t>
                       </a:r>
                       <a:endParaRPr lang="en-US" sz="1500" dirty="0"/>
                     </a:p>
@@ -14277,7 +14277,7 @@
                             <a:schemeClr val="tx2"/>
                           </a:solidFill>
                         </a:rPr>
-                        <a:t>R$ 308 mil</a:t>
+                        <a:t>R$ 391 mil</a:t>
                       </a:r>
                       <a:endParaRPr lang="en-US" sz="1500" dirty="0"/>
                     </a:p>

</xml_diff>

<commit_message>
Andares 4-5 sob a separação, 2 zonas por lado, sinal de baixo giro
- Andares 4-5 do alto giro por baixo da esteira de separação, com 2 zonas
  (P001-P005 e P006-P010) e 1 display E+Q cada
- Baixo giro com 2 zonas por lado; E+Q por estação passa de 12 para 6
- P015 ocupa a frente do bloco inteiro (1 m); corredor de ~1,5 m
- Barra luminosa âmbar na frente do operador quando a caixa tem itens no
  baixo giro (SINAL_BG pela saída extra do nó do prédio 005)
- Câmera "Visão do operador" (altura dos olhos), além de "Atrás do operador"
- dados.js gerado por projeto/dados/gerar_dados_js.py
- Diagramas, documento (v1.4), apresentação e orçamento atualizados

Co-Authored-By: Claude Opus 5.5 <noreply@anthropic.com>
Claude-Session: https://claude.ai/code/session_01TBWA3G7ku1j3oTf4VMkLud
</commit_message>
<xml_diff>
--- a/projeto/entregaveis/Apresentacao_PTL.pptx
+++ b/projeto/entregaveis/Apresentacao_PTL.pptx
@@ -129,7 +129,7 @@
   <p:extLst>
     <p:ext uri="{521415D9-36F7-43E2-AB2F-B90AF26B5E84}">
       <p14:sectionLst xmlns:p14="http://schemas.microsoft.com/office/powerpoint/2010/main">
-        <p14:section name="Abertura" id="{b76fe437-2aa2-88fb-1a2d-6ce287c26cfa}">
+        <p14:section name="Abertura" id="{16fe3566-2506-e7a6-62e1-c2946519f2ab}">
           <p14:sldIdLst>
             <p14:sldId id="256"/>
             <p14:sldId id="257"/>
@@ -137,7 +137,7 @@
             <p14:sldId id="259"/>
           </p14:sldIdLst>
         </p14:section>
-        <p14:section name="Arquiteturas" id="{f35eced5-b573-9560-aa7b-0b2cf7b91c67}">
+        <p14:section name="Arquiteturas" id="{a2d957e9-5dd5-1461-2b74-ad2cbf67cfef}">
           <p14:sldIdLst>
             <p14:sldId id="260"/>
             <p14:sldId id="261"/>
@@ -146,7 +146,7 @@
             <p14:sldId id="264"/>
           </p14:sldIdLst>
         </p14:section>
-        <p14:section name="A estação" id="{410ab448-d616-acac-7e81-ed5c15037c99}">
+        <p14:section name="A estação" id="{d73a367a-b3dc-252f-4911-d13ff0281f3c}">
           <p14:sldIdLst>
             <p14:sldId id="265"/>
             <p14:sldId id="266"/>
@@ -157,14 +157,14 @@
             <p14:sldId id="271"/>
           </p14:sldIdLst>
         </p14:section>
-        <p14:section name="Orçamento" id="{c4001bc6-1bfc-1c3e-7942-c2be93061b17}">
+        <p14:section name="Orçamento" id="{518e11f1-00a7-819f-9bb1-f14842831c46}">
           <p14:sldIdLst>
             <p14:sldId id="272"/>
             <p14:sldId id="273"/>
             <p14:sldId id="274"/>
           </p14:sldIdLst>
         </p14:section>
-        <p14:section name="Próximos passos" id="{d4724606-ffe6-9a22-b298-5018c62a8e7f}">
+        <p14:section name="Próximos passos" id="{63dcb5a7-7c57-2d68-bae4-e9ca7d6715b0}">
           <p14:sldIdLst>
             <p14:sldId id="275"/>
             <p14:sldId id="276"/>
@@ -283,10 +283,10 @@
                     <c:v>B2, RFID com leitor fixo</c:v>
                   </c:pt>
                   <c:pt idx="3">
-                    <c:v>B1, RFID com pulseira</c:v>
+                    <c:v>A com placa própria (EMS)</c:v>
                   </c:pt>
                   <c:pt idx="4">
-                    <c:v>A com placa própria (EMS)</c:v>
+                    <c:v>B1, RFID com pulseira</c:v>
                   </c:pt>
                   <c:pt idx="5">
                     <c:v>A com PTL comercial</c:v>
@@ -302,22 +302,22 @@
                 <c:formatCode>General</c:formatCode>
                 <c:ptCount val="6"/>
                 <c:pt idx="0">
-                  <c:v>260</c:v>
+                  <c:v>222</c:v>
                 </c:pt>
                 <c:pt idx="1">
-                  <c:v>356</c:v>
+                  <c:v>305</c:v>
                 </c:pt>
                 <c:pt idx="2">
-                  <c:v>383</c:v>
+                  <c:v>332</c:v>
                 </c:pt>
                 <c:pt idx="3">
-                  <c:v>389</c:v>
+                  <c:v>335</c:v>
                 </c:pt>
                 <c:pt idx="4">
-                  <c:v>405</c:v>
+                  <c:v>338</c:v>
                 </c:pt>
                 <c:pt idx="5">
-                  <c:v>929</c:v>
+                  <c:v>763</c:v>
                 </c:pt>
               </c:numCache>
             </c:numRef>
@@ -1039,7 +1039,7 @@
           <a:p>
             <a:r>
               <a:rPr lang="en-US" dirty="0"/>
-              <a:t>Esteira de transporte e de separação lado a lado, a uns 20 cm uma da outra. A transferência passa a bacia para a separação e o rolete direcionador manda para 2 estações à esquerda ou 2 à direita (ex.: entre 11 e 12 atende 10 a 13; na ponta, entre 3 e 4 atende 3, 4 e 5). A bacia só entra nas estações com itens do pedido. Alto giro na frente do operador, com a esteira de transporte passando por dentro (por baixo do andar 3 e por cima do andar 4) e a de separação aberta na frente; corredor do baixo giro atrás do operador, com 020-031 à esquerda e 043 a 032 à direita; o 015 fica na frente do bloco da direita, virado para a esteira. Medidas do desenho: 2,5 m de alto giro por estação, corredor de 1,2 m, prateleiras de 50 cm × 2 m. O concentrador fica atrás da estação e o barramento do baixo giro passa por cima das esteiras.</a:t>
+              <a:t>Esteira de transporte e de separação lado a lado, a uns 20 cm uma da outra. A transferência passa a bacia para a separação e o rolete direcionador manda para 2 estações à esquerda ou 2 à direita (ex.: entre 11 e 12 atende 10 a 13; na ponta, entre 3 e 4 atende 3, 4 e 5). A bacia só entra nas estações com itens do pedido. Alto giro na frente do operador, com a esteira de transporte passando por dentro (por baixo do andar 3 e por cima do andar 4) e a de separação aberta na frente; corredor do baixo giro atrás do operador, com 020-031 à esquerda e 043 a 032 à direita; o 015 ocupa a frente do bloco inteiro (1 m), virado para a esteira. Andares 4 e 5 do alto giro por baixo da esteira de separação. Medidas do desenho: 2,5 m de alto giro por estação, blocos de 1 m (2 prateleiras de 50 cm × 2 m) e corredor de cerca de 1,5 m. A barra âmbar na frente do alto giro avisa que a caixa tem itens no baixo giro. O concentrador fica atrás da estação e o barramento do baixo giro passa por cima das esteiras.</a:t>
             </a:r>
             <a:endParaRPr lang="en-US" dirty="0"/>
           </a:p>
@@ -1127,7 +1127,7 @@
           <a:p>
             <a:r>
               <a:rPr lang="en-US" dirty="0"/>
-              <a:t>Prateleiras alinhadas; a caixa do endereço muda de tamanho pelo tipo. Estação 05: 209 endereços. 49 de alto giro (29 com display próprio e 20 nos andares 4 e 5, atendidos por quatro displays) e 160 de baixo giro em 8 zonas (4 por lado, displays na altura dos olhos). O tamanho da zona é parâmetro e será ajustado no piloto.</a:t>
+              <a:t>Prateleiras alinhadas; a caixa do endereço muda de tamanho pelo tipo. Estação 05: 209 endereços. 49 de alto giro (29 com display próprio e 20 nos andares 4 e 5, atendidos por dois displays) e 160 de baixo giro em 4 zonas (2 por lado, displays na altura dos olhos). O tamanho da zona é parâmetro e será ajustado no piloto.</a:t>
             </a:r>
             <a:endParaRPr lang="en-US" dirty="0"/>
           </a:p>
@@ -1743,7 +1743,7 @@
           <a:p>
             <a:r>
               <a:rPr lang="en-US" dirty="0"/>
-              <a:t>Valores com instalação. 12 V × 5 V: os materiais ficam praticamente iguais (R$ 260 mil × R$ 263 mil), porque o cabo de força extra do 5 V custa mais do que os reguladores economizados, e o 5 V ainda aumenta a manutenção. Por isso a indicação é 12 V.</a:t>
+              <a:t>Valores com instalação. 12 V × 5 V: os materiais ficam praticamente iguais (R$ 222 mil × R$ 227 mil), porque o cabo de força extra do 5 V custa mais do que os reguladores economizados, e o 5 V ainda aumenta a manutenção. Por isso a indicação é 12 V.</a:t>
             </a:r>
             <a:endParaRPr lang="en-US" dirty="0"/>
           </a:p>
@@ -4254,7 +4254,7 @@
                   <a:schemeClr val="accent6"/>
                 </a:solidFill>
               </a:rPr>
-              <a:t>quatro displays de endereço e quantidade (A4 e A5 em cada lado)</a:t>
+              <a:t>duas zonas, cada uma com um display de endereço e quantidade, por baixo da esteira de separação</a:t>
             </a:r>
             <a:endParaRPr lang="en-US" sz="1200" dirty="0"/>
           </a:p>
@@ -4326,7 +4326,7 @@
                   <a:schemeClr val="accent6"/>
                 </a:solidFill>
               </a:rPr>
-              <a:t>quatro zonas por lado, com display na altura dos olhos</a:t>
+              <a:t>duas zonas por lado, com display na altura dos olhos, e sinal luminoso na frente do operador</a:t>
             </a:r>
             <a:endParaRPr lang="en-US" sz="1200" dirty="0"/>
           </a:p>
@@ -6373,7 +6373,7 @@
                             <a:schemeClr val="tx2"/>
                           </a:solidFill>
                         </a:rPr>
-                        <a:t>16.431</a:t>
+                        <a:t>14.511</a:t>
                       </a:r>
                       <a:endParaRPr lang="en-US" sz="1300" dirty="0"/>
                     </a:p>
@@ -6491,7 +6491,7 @@
                             <a:schemeClr val="tx2"/>
                           </a:solidFill>
                         </a:rPr>
-                        <a:t>21.806</a:t>
+                        <a:t>19.211</a:t>
                       </a:r>
                       <a:endParaRPr lang="en-US" sz="1300" dirty="0"/>
                     </a:p>
@@ -6609,7 +6609,7 @@
                             <a:schemeClr val="tx2"/>
                           </a:solidFill>
                         </a:rPr>
-                        <a:t>23.144</a:t>
+                        <a:t>20.550</a:t>
                       </a:r>
                       <a:endParaRPr lang="en-US" sz="1300" dirty="0"/>
                     </a:p>
@@ -6727,7 +6727,7 @@
                             <a:schemeClr val="tx2"/>
                           </a:solidFill>
                         </a:rPr>
-                        <a:t>38.473</a:t>
+                        <a:t>34.967</a:t>
                       </a:r>
                       <a:endParaRPr lang="en-US" sz="1300" dirty="0"/>
                     </a:p>
@@ -6845,7 +6845,7 @@
                             <a:schemeClr val="tx2"/>
                           </a:solidFill>
                         </a:rPr>
-                        <a:t>50.062</a:t>
+                        <a:t>41.681</a:t>
                       </a:r>
                       <a:endParaRPr lang="en-US" sz="1300" dirty="0"/>
                     </a:p>
@@ -6924,7 +6924,7 @@
                   <a:schemeClr val="accent6"/>
                 </a:solidFill>
               </a:rPr>
-              <a:t>Software interno: cerca de 1.144 h (A) e 1.064 h (B), ou R$ 119 mil e R$ 110 mil. Com 10% de contingência e o software, a Arquitetura A soma cerca de R$ 510 mil.</a:t>
+              <a:t>Software interno: cerca de 1.144 h (A) e 1.064 h (B), ou R$ 119 mil e R$ 110 mil. Com 10% de contingência e o software, a Arquitetura A soma cerca de R$ 454 mil.</a:t>
             </a:r>
             <a:endParaRPr lang="en-US" sz="1200" dirty="0"/>
           </a:p>
@@ -7163,7 +7163,7 @@
                   <a:schemeClr val="accent2"/>
                 </a:solidFill>
               </a:rPr>
-              <a:t>R$ 356 mil</a:t>
+              <a:t>R$ 305 mil</a:t>
             </a:r>
             <a:endParaRPr lang="en-US" sz="3000" dirty="0"/>
           </a:p>
@@ -7424,7 +7424,7 @@
                   <a:schemeClr val="accent3"/>
                 </a:solidFill>
               </a:rPr>
-              <a:t>R$ 405 mil</a:t>
+              <a:t>R$ 335 mil</a:t>
             </a:r>
             <a:endParaRPr lang="en-US" sz="3000" dirty="0"/>
           </a:p>
@@ -7685,7 +7685,7 @@
                   <a:schemeClr val="accent5"/>
                 </a:solidFill>
               </a:rPr>
-              <a:t>R$ 929 mil</a:t>
+              <a:t>R$ 763 mil</a:t>
             </a:r>
             <a:endParaRPr lang="en-US" sz="3000" dirty="0"/>
           </a:p>
@@ -8265,7 +8265,7 @@
                 <a:ea typeface="Arial" pitchFamily="34" charset="-122"/>
                 <a:cs typeface="Arial" pitchFamily="34" charset="-120"/>
               </a:rPr>
-              <a:t>R$ 356 mil</a:t>
+              <a:t>R$ 305 mil</a:t>
             </a:r>
             <a:endParaRPr lang="en-US" sz="3000" dirty="0"/>
           </a:p>
@@ -8403,7 +8403,7 @@
                 <a:ea typeface="Arial" pitchFamily="34" charset="-122"/>
                 <a:cs typeface="Arial" pitchFamily="34" charset="-120"/>
               </a:rPr>
-              <a:t>R$ 21,8 mil</a:t>
+              <a:t>R$ 19,2 mil</a:t>
             </a:r>
             <a:endParaRPr lang="en-US" sz="3000" dirty="0"/>
           </a:p>
@@ -11106,7 +11106,7 @@
                   <a:srgbClr val="C9D3E0"/>
                 </a:solidFill>
               </a:rPr>
-              <a:t>1. Aprovar o piloto nas estações 05 e 27 (cerca de R$ 22 mil)</a:t>
+              <a:t>1. Aprovar o piloto nas estações 05 e 27 (cerca de R$ 19 mil)</a:t>
             </a:r>
             <a:endParaRPr lang="en-US" sz="2000" dirty="0"/>
           </a:p>
@@ -14459,7 +14459,7 @@
                             <a:schemeClr val="tx2"/>
                           </a:solidFill>
                         </a:rPr>
-                        <a:t>R$ 356 mil</a:t>
+                        <a:t>R$ 305 mil</a:t>
                       </a:r>
                       <a:endParaRPr lang="en-US" sz="1500" dirty="0"/>
                     </a:p>
@@ -14517,7 +14517,7 @@
                             <a:schemeClr val="tx2"/>
                           </a:solidFill>
                         </a:rPr>
-                        <a:t>R$ 383 mil</a:t>
+                        <a:t>R$ 332 mil</a:t>
                       </a:r>
                       <a:endParaRPr lang="en-US" sz="1500" dirty="0"/>
                     </a:p>

</xml_diff>

<commit_message>
POC das estações 04 e 27, caixas maiores e sem luzes no topo
- Aba POC no orçamento: fase 1 (bancada) e fase 2 (estações 04 e 27),
  contingência e horas de software da POC; piloto passa a ser 04 e 27
- Diagrama do mockup da bancada (bancada_poc.png)
- 3D: sem LED guia e sem produtos coloridos em cima das caixas; caixas
  ocupam a largura do vão
- LED guia de coluna retirado do orçamento, do documento e dos diagramas

Co-Authored-By: Claude Opus 5.5 <noreply@anthropic.com>
Claude-Session: https://claude.ai/code/session_01TBWA3G7ku1j3oTf4VMkLud
</commit_message>
<xml_diff>
--- a/projeto/entregaveis/Apresentacao_PTL.pptx
+++ b/projeto/entregaveis/Apresentacao_PTL.pptx
@@ -129,7 +129,7 @@
   <p:extLst>
     <p:ext uri="{521415D9-36F7-43E2-AB2F-B90AF26B5E84}">
       <p14:sectionLst xmlns:p14="http://schemas.microsoft.com/office/powerpoint/2010/main">
-        <p14:section name="Abertura" id="{16fe3566-2506-e7a6-62e1-c2946519f2ab}">
+        <p14:section name="Abertura" id="{71a9784f-919e-75ce-81e2-fcb83afc3b7e}">
           <p14:sldIdLst>
             <p14:sldId id="256"/>
             <p14:sldId id="257"/>
@@ -137,7 +137,7 @@
             <p14:sldId id="259"/>
           </p14:sldIdLst>
         </p14:section>
-        <p14:section name="Arquiteturas" id="{a2d957e9-5dd5-1461-2b74-ad2cbf67cfef}">
+        <p14:section name="Arquiteturas" id="{fdfb8c43-6ded-fdef-2c7e-bcab0c2cb790}">
           <p14:sldIdLst>
             <p14:sldId id="260"/>
             <p14:sldId id="261"/>
@@ -146,7 +146,7 @@
             <p14:sldId id="264"/>
           </p14:sldIdLst>
         </p14:section>
-        <p14:section name="A estação" id="{d73a367a-b3dc-252f-4911-d13ff0281f3c}">
+        <p14:section name="A estação" id="{3950bc72-394c-a112-0bd4-585b1cb1c116}">
           <p14:sldIdLst>
             <p14:sldId id="265"/>
             <p14:sldId id="266"/>
@@ -157,14 +157,14 @@
             <p14:sldId id="271"/>
           </p14:sldIdLst>
         </p14:section>
-        <p14:section name="Orçamento" id="{518e11f1-00a7-819f-9bb1-f14842831c46}">
+        <p14:section name="Orçamento" id="{9c628e52-82b1-96f5-9da2-e3fd2018c072}">
           <p14:sldIdLst>
             <p14:sldId id="272"/>
             <p14:sldId id="273"/>
             <p14:sldId id="274"/>
           </p14:sldIdLst>
         </p14:section>
-        <p14:section name="Próximos passos" id="{63dcb5a7-7c57-2d68-bae4-e9ca7d6715b0}">
+        <p14:section name="Próximos passos" id="{797216b1-7c55-5844-87ba-96ab7d9a9607}">
           <p14:sldIdLst>
             <p14:sldId id="275"/>
             <p14:sldId id="276"/>
@@ -6191,7 +6191,7 @@
                             <a:schemeClr val="bg1"/>
                           </a:solidFill>
                         </a:rPr>
-                        <a:t>Piloto 05 e 27</a:t>
+                        <a:t>Piloto 04 e 27</a:t>
                       </a:r>
                       <a:endParaRPr lang="en-US" sz="1300" dirty="0"/>
                     </a:p>
@@ -8403,7 +8403,7 @@
                 <a:ea typeface="Arial" pitchFamily="34" charset="-122"/>
                 <a:cs typeface="Arial" pitchFamily="34" charset="-120"/>
               </a:rPr>
-              <a:t>R$ 19,2 mil</a:t>
+              <a:t>R$ 22,5 mil</a:t>
             </a:r>
             <a:endParaRPr lang="en-US" sz="3000" dirty="0"/>
           </a:p>
@@ -8439,7 +8439,7 @@
                   <a:schemeClr val="tx2"/>
                 </a:solidFill>
               </a:rPr>
-              <a:t>piloto</a:t>
+              <a:t>POC</a:t>
             </a:r>
             <a:endParaRPr lang="en-US" sz="1600" dirty="0"/>
           </a:p>
@@ -8475,7 +8475,7 @@
                   <a:schemeClr val="accent6"/>
                 </a:solidFill>
               </a:rPr>
-              <a:t>estações 05 e 27</a:t>
+              <a:t>bancada + estações 04 e 27</a:t>
             </a:r>
             <a:endParaRPr lang="en-US" sz="1300" dirty="0"/>
           </a:p>
@@ -8522,7 +8522,7 @@
                   <a:schemeClr val="tx2"/>
                 </a:solidFill>
               </a:rPr>
-              <a:t>começar pela Arquitetura A, que usa os coletores MovFast que já temos, com os módulos montados internamente e alimentação em 12 V. O piloto seria nas estações 05 e 27. A Arquitetura B (RFID) pode vir depois, aproveitando os mesmos displays.</a:t>
+              <a:t>começar pela Arquitetura A, que usa os coletores MovFast que já temos, com os módulos montados internamente e alimentação em 12 V. O piloto seria nas estações 04 e 27. A Arquitetura B (RFID) pode vir depois, aproveitando os mesmos displays.</a:t>
             </a:r>
             <a:endParaRPr lang="en-US" sz="1700" dirty="0"/>
           </a:p>
@@ -8955,7 +8955,7 @@
                   <a:schemeClr val="accent1"/>
                 </a:solidFill>
               </a:rPr>
-              <a:t>6 a 8 sem.</a:t>
+              <a:t>~10 sem.</a:t>
             </a:r>
             <a:endParaRPr lang="en-US" sz="1400" dirty="0"/>
           </a:p>
@@ -8991,7 +8991,7 @@
                   <a:schemeClr val="tx1"/>
                 </a:solidFill>
               </a:rPr>
-              <a:t>Piloto 05 e 27</a:t>
+              <a:t>POC 04 e 27</a:t>
             </a:r>
             <a:endParaRPr lang="en-US" sz="1700" dirty="0"/>
           </a:p>
@@ -9027,7 +9027,7 @@
                   <a:schemeClr val="accent6"/>
                 </a:solidFill>
               </a:rPr>
-              <a:t>Estações completas, app do coletor, painel e medição antes e depois</a:t>
+              <a:t>Bancada, depois as 2 estações completas, app do coletor e medição antes e depois</a:t>
             </a:r>
             <a:endParaRPr lang="en-US" sz="1300" dirty="0"/>
           </a:p>
@@ -11106,7 +11106,7 @@
                   <a:srgbClr val="C9D3E0"/>
                 </a:solidFill>
               </a:rPr>
-              <a:t>1. Aprovar o piloto nas estações 05 e 27 (cerca de R$ 19 mil)</a:t>
+              <a:t>1. Aprovar a POC: bancada + estações 04 e 27 (cerca de R$ 22,5 mil)</a:t>
             </a:r>
             <a:endParaRPr lang="en-US" sz="2000" dirty="0"/>
           </a:p>

</xml_diff>

<commit_message>
Foco no coletor; leitor fixo retirado e RFID como melhoria futura
- Orçamento: aba B-RFID vira RFID-futuro (tags + pulseiras como acréscimo,
  fora do investimento); B2 retirado; software do RFID separado
- Documento (v1.5), apresentação e diagramas: Arquitetura A na POC e na
  implantação; RFID com pulseira como melhoria futura
- Simulador: sem o modo B2; pulseira marcada como melhoria futura

Co-Authored-By: Claude Opus 5.5 <noreply@anthropic.com>
Claude-Session: https://claude.ai/code/session_01TBWA3G7ku1j3oTf4VMkLud
</commit_message>
<xml_diff>
--- a/projeto/entregaveis/Apresentacao_PTL.pptx
+++ b/projeto/entregaveis/Apresentacao_PTL.pptx
@@ -129,7 +129,7 @@
   <p:extLst>
     <p:ext uri="{521415D9-36F7-43E2-AB2F-B90AF26B5E84}">
       <p14:sectionLst xmlns:p14="http://schemas.microsoft.com/office/powerpoint/2010/main">
-        <p14:section name="Abertura" id="{71a9784f-919e-75ce-81e2-fcb83afc3b7e}">
+        <p14:section name="Abertura" id="{d979ba18-9091-21b9-4ac6-c97afe29dea9}">
           <p14:sldIdLst>
             <p14:sldId id="256"/>
             <p14:sldId id="257"/>
@@ -137,7 +137,7 @@
             <p14:sldId id="259"/>
           </p14:sldIdLst>
         </p14:section>
-        <p14:section name="Arquiteturas" id="{fdfb8c43-6ded-fdef-2c7e-bcab0c2cb790}">
+        <p14:section name="Arquiteturas" id="{8c635f28-556c-797e-436f-8f2a6d476606}">
           <p14:sldIdLst>
             <p14:sldId id="260"/>
             <p14:sldId id="261"/>
@@ -146,7 +146,7 @@
             <p14:sldId id="264"/>
           </p14:sldIdLst>
         </p14:section>
-        <p14:section name="A estação" id="{3950bc72-394c-a112-0bd4-585b1cb1c116}">
+        <p14:section name="A estação" id="{5f311888-c59b-eaa9-ff89-2ce66ff61c3b}">
           <p14:sldIdLst>
             <p14:sldId id="265"/>
             <p14:sldId id="266"/>
@@ -157,14 +157,14 @@
             <p14:sldId id="271"/>
           </p14:sldIdLst>
         </p14:section>
-        <p14:section name="Orçamento" id="{9c628e52-82b1-96f5-9da2-e3fd2018c072}">
+        <p14:section name="Orçamento" id="{c923354d-0549-af86-3d9a-846e006732b6}">
           <p14:sldIdLst>
             <p14:sldId id="272"/>
             <p14:sldId id="273"/>
             <p14:sldId id="274"/>
           </p14:sldIdLst>
         </p14:section>
-        <p14:section name="Próximos passos" id="{797216b1-7c55-5844-87ba-96ab7d9a9607}">
+        <p14:section name="Próximos passos" id="{db961531-1a75-ac23-d499-25a64629ff2d}">
           <p14:sldIdLst>
             <p14:sldId id="275"/>
             <p14:sldId id="276"/>
@@ -269,9 +269,9 @@
           </c:dLbls>
           <c:cat>
             <c:multiLvlStrRef>
-              <c:f>Sheet1!$A$2:$A$7</c:f>
+              <c:f>Sheet1!$A$2:$A$5</c:f>
               <c:multiLvlStrCache>
-                <c:ptCount val="6"/>
+                <c:ptCount val="4"/>
                 <c:lvl>
                   <c:pt idx="0">
                     <c:v>A interna, só materiais</c:v>
@@ -280,15 +280,9 @@
                     <c:v>A interna, com mão de obra</c:v>
                   </c:pt>
                   <c:pt idx="2">
-                    <c:v>B2, RFID com leitor fixo</c:v>
+                    <c:v>A com placa própria (EMS)</c:v>
                   </c:pt>
                   <c:pt idx="3">
-                    <c:v>A com placa própria (EMS)</c:v>
-                  </c:pt>
-                  <c:pt idx="4">
-                    <c:v>B1, RFID com pulseira</c:v>
-                  </c:pt>
-                  <c:pt idx="5">
                     <c:v>A com PTL comercial</c:v>
                   </c:pt>
                 </c:lvl>
@@ -297,10 +291,10 @@
           </c:cat>
           <c:val>
             <c:numRef>
-              <c:f>Sheet1!$B$2:$B$7</c:f>
+              <c:f>Sheet1!$B$2:$B$5</c:f>
               <c:numCache>
                 <c:formatCode>General</c:formatCode>
-                <c:ptCount val="6"/>
+                <c:ptCount val="4"/>
                 <c:pt idx="0">
                   <c:v>222</c:v>
                 </c:pt>
@@ -308,15 +302,9 @@
                   <c:v>305</c:v>
                 </c:pt>
                 <c:pt idx="2">
-                  <c:v>332</c:v>
+                  <c:v>335</c:v>
                 </c:pt>
                 <c:pt idx="3">
-                  <c:v>335</c:v>
-                </c:pt>
-                <c:pt idx="4">
-                  <c:v>338</c:v>
-                </c:pt>
-                <c:pt idx="5">
                   <c:v>763</c:v>
                 </c:pt>
               </c:numCache>
@@ -2623,7 +2611,7 @@
           <a:p>
             <a:r>
               <a:rPr lang="en-US" dirty="0"/>
-              <a:t>Azul: software novo (Serviço PTL). Verde: hardware novo em cada estação. Marrom: sistemas que já existem. Tracejado: opcional ou só na Arquitetura B. O serviço fala com o Sybase por SQL, com o BHT por HTTP e com os 40 concentradores por MQTT na rede cabeada; cada concentrador comanda dois barramentos RS-485.</a:t>
+              <a:t>Azul: software novo (Serviço PTL). Verde: hardware novo em cada estação. Marrom: sistemas que já existem. Tracejado: opcional ou melhoria futura (RFID com pulseira). O serviço fala com o Sybase por SQL, com o BHT por HTTP e com os 40 concentradores por MQTT na rede cabeada; cada concentrador comanda dois barramentos RS-485.</a:t>
             </a:r>
             <a:endParaRPr lang="en-US" dirty="0"/>
           </a:p>
@@ -2799,7 +2787,7 @@
           <a:p>
             <a:r>
               <a:rPr lang="en-US" dirty="0"/>
-              <a:t>Valores com mão de obra interna. A B usa toda a parte de displays da A, então começar pela A não desperdiça investimento.</a:t>
+              <a:t>Valores com mão de obra interna. O RFID usa toda a parte de displays da A, então começar pelo coletor não desperdiça investimento.</a:t>
             </a:r>
             <a:endParaRPr lang="en-US" dirty="0"/>
           </a:p>
@@ -6551,7 +6539,7 @@
                             <a:schemeClr val="tx2"/>
                           </a:solidFill>
                         </a:rPr>
-                        <a:t>B2, leitor fixo</a:t>
+                        <a:t>POC com contingência</a:t>
                       </a:r>
                       <a:endParaRPr lang="en-US" sz="1300" dirty="0"/>
                     </a:p>
@@ -6609,7 +6597,7 @@
                             <a:schemeClr val="tx2"/>
                           </a:solidFill>
                         </a:rPr>
-                        <a:t>20.550</a:t>
+                        <a:t>22.469</a:t>
                       </a:r>
                       <a:endParaRPr lang="en-US" sz="1300" dirty="0"/>
                     </a:p>
@@ -6924,7 +6912,7 @@
                   <a:schemeClr val="accent6"/>
                 </a:solidFill>
               </a:rPr>
-              <a:t>Software interno: cerca de 1.144 h (A) e 1.064 h (B), ou R$ 119 mil e R$ 110 mil. Com 10% de contingência e o software, a Arquitetura A soma cerca de R$ 454 mil.</a:t>
+              <a:t>Software interno: cerca de 1.144 h, ou R$ 119 mil. RFID futuro: + R$ 33 mil e 80 h. Com 10% de contingência e o software, a Arquitetura A soma cerca de R$ 454 mil.</a:t>
             </a:r>
             <a:endParaRPr lang="en-US" sz="1200" dirty="0"/>
           </a:p>
@@ -8522,7 +8510,7 @@
                   <a:schemeClr val="tx2"/>
                 </a:solidFill>
               </a:rPr>
-              <a:t>começar pela Arquitetura A, que usa os coletores MovFast que já temos, com os módulos montados internamente e alimentação em 12 V. O piloto seria nas estações 04 e 27. A Arquitetura B (RFID) pode vir depois, aproveitando os mesmos displays.</a:t>
+              <a:t>começar pela Arquitetura A, que usa os coletores MovFast que já temos, com os módulos montados internamente e alimentação em 12 V. O piloto seria nas estações 04 e 27. O RFID com pulseira fica como melhoria futura, aproveitando os mesmos displays.</a:t>
             </a:r>
             <a:endParaRPr lang="en-US" sz="1700" dirty="0"/>
           </a:p>
@@ -10881,7 +10869,7 @@
                   <a:schemeClr val="tx2"/>
                 </a:solidFill>
               </a:rPr>
-              <a:t>Leitura no coletor virtual ou por RFID</a:t>
+              <a:t>Leitura da caixa no coletor virtual</a:t>
             </a:r>
             <a:endParaRPr lang="en-US" sz="1400" dirty="0"/>
           </a:p>
@@ -12558,7 +12546,7 @@
                   <a:schemeClr val="accent4"/>
                 </a:solidFill>
               </a:rPr>
-              <a:t>Na Arquitetura B, os passos 1 e 4 são feitos pela leitura da tag RFID fixa na caixa.</a:t>
+              <a:t>No futuro, com RFID, os passos 1 e 4 passam a ser feitos encostando a pulseira na tag da caixa.</a:t>
             </a:r>
             <a:endParaRPr lang="en-US" sz="1400" dirty="0"/>
           </a:p>
@@ -12704,7 +12692,7 @@
                   <a:srgbClr val="C9D3E0"/>
                 </a:solidFill>
               </a:rPr>
-              <a:t>As duas usam os mesmos displays. Muda apenas como a caixa é identificada: pelo coletor (A) ou por RFID (B).</a:t>
+              <a:t>A POC e a implantação usam o coletor que já temos. O RFID com pulseira usa os mesmos displays e fica como melhoria futura.</a:t>
             </a:r>
             <a:endParaRPr lang="en-US" sz="1800" dirty="0"/>
           </a:p>
@@ -13387,7 +13375,7 @@
                   <a:schemeClr val="tx1"/>
                 </a:solidFill>
               </a:rPr>
-              <a:t>Arquitetura B: RFID na caixa</a:t>
+              <a:t>Melhoria futura: RFID com pulseira</a:t>
             </a:r>
             <a:endParaRPr lang="en-US" sz="2600" dirty="0"/>
           </a:p>
@@ -13474,7 +13462,7 @@
                   <a:schemeClr val="accent4"/>
                 </a:solidFill>
               </a:rPr>
-              <a:t>B2: leitor fixo (indicado)</a:t>
+              <a:t>Depois da POC</a:t>
             </a:r>
             <a:endParaRPr lang="en-US" sz="1500" dirty="0"/>
           </a:p>
@@ -13510,7 +13498,7 @@
                   <a:schemeClr val="accent6"/>
                 </a:solidFill>
               </a:rPr>
-              <a:t>Leitor NFC no ponto onde a caixa para e painel LCD. O operador não carrega nada.</a:t>
+              <a:t>A POC e a implantação usam o coletor. O leitor fixo saiu do projeto.</a:t>
             </a:r>
             <a:endParaRPr lang="en-US" sz="1300" dirty="0"/>
           </a:p>
@@ -13573,7 +13561,7 @@
                   <a:schemeClr val="accent4"/>
                 </a:solidFill>
               </a:rPr>
-              <a:t>B1: pulseira NFC</a:t>
+              <a:t>Pulseira NFC</a:t>
             </a:r>
             <a:endParaRPr lang="en-US" sz="1500" dirty="0"/>
           </a:p>
@@ -13609,7 +13597,7 @@
                   <a:schemeClr val="accent6"/>
                 </a:solidFill>
               </a:rPr>
-              <a:t>Cerca de R$ 130 por unidade, mãos livres. Bateria e conforto preocupam.</a:t>
+              <a:t>Cerca de R$ 130 por unidade, mãos livres. Acréscimo de ~R$ 36 mil para as 40 estações.</a:t>
             </a:r>
             <a:endParaRPr lang="en-US" sz="1300" dirty="0"/>
           </a:p>
@@ -13816,7 +13804,7 @@
                   <a:schemeClr val="tx1"/>
                 </a:solidFill>
               </a:rPr>
-              <a:t>Comparação entre A e B</a:t>
+              <a:t>Coletor hoje, RFID depois</a:t>
             </a:r>
             <a:endParaRPr lang="en-US" sz="2600" dirty="0"/>
           </a:p>
@@ -13925,7 +13913,7 @@
                             <a:schemeClr val="bg1"/>
                           </a:solidFill>
                         </a:rPr>
-                        <a:t>A: coletor</a:t>
+                        <a:t>Coletor (POC e implantação)</a:t>
                       </a:r>
                       <a:endParaRPr lang="en-US" sz="1500" dirty="0"/>
                     </a:p>
@@ -13986,7 +13974,7 @@
                             <a:schemeClr val="bg1"/>
                           </a:solidFill>
                         </a:rPr>
-                        <a:t>B2: RFID com leitor fixo</a:t>
+                        <a:t>RFID com pulseira (futuro)</a:t>
                       </a:r>
                       <a:endParaRPr lang="en-US" sz="1500" dirty="0"/>
                     </a:p>
@@ -14165,7 +14153,7 @@
                             <a:schemeClr val="tx2"/>
                           </a:solidFill>
                         </a:rPr>
-                        <a:t>Tag em cada caixa e leitor em cada estação</a:t>
+                        <a:t>Tag em cada caixa e pulseira no operador</a:t>
                       </a:r>
                       <a:endParaRPr lang="en-US" sz="1500" dirty="0"/>
                     </a:p>
@@ -14341,7 +14329,7 @@
                             <a:schemeClr val="tx2"/>
                           </a:solidFill>
                         </a:rPr>
-                        <a:t>Posiciona a caixa (abre) e lê de novo (fecha)</a:t>
+                        <a:t>Encosta o pulso na tag para abrir e fechar</a:t>
                       </a:r>
                       <a:endParaRPr lang="en-US" sz="1500" dirty="0"/>
                     </a:p>
@@ -14517,7 +14505,7 @@
                             <a:schemeClr val="tx2"/>
                           </a:solidFill>
                         </a:rPr>
-                        <a:t>R$ 332 mil</a:t>
+                        <a:t>+ R$ 33 mil sobre o coletor</a:t>
                       </a:r>
                       <a:endParaRPr lang="en-US" sz="1500" dirty="0"/>
                     </a:p>
@@ -14811,7 +14799,7 @@
                             <a:schemeClr val="tx2"/>
                           </a:solidFill>
                         </a:rPr>
-                        <a:t>Cerca de 1.080 h</a:t>
+                        <a:t>Cerca de 1.144 h</a:t>
                       </a:r>
                       <a:endParaRPr lang="en-US" sz="1500" dirty="0"/>
                     </a:p>
@@ -14869,7 +14857,7 @@
                             <a:schemeClr val="tx2"/>
                           </a:solidFill>
                         </a:rPr>
-                        <a:t>Cerca de 1.000 h, mais o cadastro das tags</a:t>
+                        <a:t>+ 80 h e o cadastro das tags</a:t>
                       </a:r>
                       <a:endParaRPr lang="en-US" sz="1500" dirty="0"/>
                     </a:p>
@@ -15045,7 +15033,7 @@
                             <a:schemeClr val="tx2"/>
                           </a:solidFill>
                         </a:rPr>
-                        <a:t>Posição de leitura na esteira; frota de tags</a:t>
+                        <a:t>Conforto e bateria da pulseira; frota de tags</a:t>
                       </a:r>
                       <a:endParaRPr lang="en-US" sz="1500" dirty="0"/>
                     </a:p>
@@ -15163,7 +15151,7 @@
                             <a:schemeClr val="tx2"/>
                           </a:solidFill>
                         </a:rPr>
-                        <a:t>Menor</a:t>
+                        <a:t>POC em ~10 semanas</a:t>
                       </a:r>
                       <a:endParaRPr lang="en-US" sz="1500" dirty="0"/>
                     </a:p>
@@ -15221,7 +15209,7 @@
                             <a:schemeClr val="tx2"/>
                           </a:solidFill>
                         </a:rPr>
-                        <a:t>Maior, por causa das tags, do cadastro e da instalação</a:t>
+                        <a:t>Depois da POC</a:t>
                       </a:r>
                       <a:endParaRPr lang="en-US" sz="1500" dirty="0"/>
                     </a:p>

</xml_diff>

<commit_message>
Preços das peças com link: aba Fontes e Orcamento_Pecas_Fontes.xlsx
Cada peça da Arquitetura A e do RFID futuro tem loja, produto, link e
preço consultados em 27/10/2026 (fontes_precos.py). Orçamentos completo,
POC e projeto interno, documento e apresentação regenerados com os
preços novos.

Co-Authored-By: Claude Opus 5.5 <noreply@anthropic.com>
Claude-Session: https://claude.ai/code/session_01TBWA3G7ku1j3oTf4VMkLud
</commit_message>
<xml_diff>
--- a/projeto/entregaveis/Apresentacao_PTL.pptx
+++ b/projeto/entregaveis/Apresentacao_PTL.pptx
@@ -129,7 +129,7 @@
   <p:extLst>
     <p:ext uri="{521415D9-36F7-43E2-AB2F-B90AF26B5E84}">
       <p14:sectionLst xmlns:p14="http://schemas.microsoft.com/office/powerpoint/2010/main">
-        <p14:section name="Abertura" id="{d979ba18-9091-21b9-4ac6-c97afe29dea9}">
+        <p14:section name="Abertura" id="{27d3931a-97a2-78cc-7020-26a63fa108e4}">
           <p14:sldIdLst>
             <p14:sldId id="256"/>
             <p14:sldId id="257"/>
@@ -137,7 +137,7 @@
             <p14:sldId id="259"/>
           </p14:sldIdLst>
         </p14:section>
-        <p14:section name="Arquiteturas" id="{8c635f28-556c-797e-436f-8f2a6d476606}">
+        <p14:section name="Arquiteturas" id="{a4639e5c-ec6b-2bfb-6c76-d75b7e8bfbcb}">
           <p14:sldIdLst>
             <p14:sldId id="260"/>
             <p14:sldId id="261"/>
@@ -146,7 +146,7 @@
             <p14:sldId id="264"/>
           </p14:sldIdLst>
         </p14:section>
-        <p14:section name="A estação" id="{5f311888-c59b-eaa9-ff89-2ce66ff61c3b}">
+        <p14:section name="A estação" id="{2e95718c-474f-e830-d488-f80e8af74993}">
           <p14:sldIdLst>
             <p14:sldId id="265"/>
             <p14:sldId id="266"/>
@@ -157,14 +157,14 @@
             <p14:sldId id="271"/>
           </p14:sldIdLst>
         </p14:section>
-        <p14:section name="Orçamento" id="{c923354d-0549-af86-3d9a-846e006732b6}">
+        <p14:section name="Orçamento" id="{93a97ab9-e0b8-85e1-31f0-7c3ee2af3598}">
           <p14:sldIdLst>
             <p14:sldId id="272"/>
             <p14:sldId id="273"/>
             <p14:sldId id="274"/>
           </p14:sldIdLst>
         </p14:section>
-        <p14:section name="Próximos passos" id="{db961531-1a75-ac23-d499-25a64629ff2d}">
+        <p14:section name="Próximos passos" id="{edb41b84-0f12-70d9-cf50-b28c4553ebb2}">
           <p14:sldIdLst>
             <p14:sldId id="275"/>
             <p14:sldId id="276"/>
@@ -296,16 +296,16 @@
                 <c:formatCode>General</c:formatCode>
                 <c:ptCount val="4"/>
                 <c:pt idx="0">
-                  <c:v>222</c:v>
+                  <c:v>244</c:v>
                 </c:pt>
                 <c:pt idx="1">
-                  <c:v>305</c:v>
+                  <c:v>326</c:v>
                 </c:pt>
                 <c:pt idx="2">
-                  <c:v>335</c:v>
+                  <c:v>342</c:v>
                 </c:pt>
                 <c:pt idx="3">
-                  <c:v>763</c:v>
+                  <c:v>754</c:v>
                 </c:pt>
               </c:numCache>
             </c:numRef>
@@ -1731,7 +1731,7 @@
           <a:p>
             <a:r>
               <a:rPr lang="en-US" dirty="0"/>
-              <a:t>Valores com instalação. 12 V × 5 V: os materiais ficam praticamente iguais (R$ 222 mil × R$ 227 mil), porque o cabo de força extra do 5 V custa mais do que os reguladores economizados, e o 5 V ainda aumenta a manutenção. Por isso a indicação é 12 V.</a:t>
+              <a:t>Valores com instalação. 12 V × 5 V: o 5 V fica mais caro (R$ 244 mil × R$ 264 mil em materiais), porque a fonte de 5 V e o cabo de força extra custam mais do que os reguladores economizados, e o 5 V ainda aumenta a manutenção. Por isso a indicação é 12 V.</a:t>
             </a:r>
             <a:endParaRPr lang="en-US" dirty="0"/>
           </a:p>
@@ -6008,7 +6008,7 @@
                   <a:srgbClr val="C9D3E0"/>
                 </a:solidFill>
               </a:rPr>
-              <a:t>Preços pesquisados em lojas brasileiras em 23 e 26/10/2026. Os itens estimados estão marcados na planilha.</a:t>
+              <a:t>Preços de lojas on-line consultados em 27/10/2026, cada um com o link na planilha (aba Fontes).</a:t>
             </a:r>
             <a:endParaRPr lang="en-US" sz="1800" dirty="0"/>
           </a:p>
@@ -6361,7 +6361,7 @@
                             <a:schemeClr val="tx2"/>
                           </a:solidFill>
                         </a:rPr>
-                        <a:t>14.511</a:t>
+                        <a:t>15.479</a:t>
                       </a:r>
                       <a:endParaRPr lang="en-US" sz="1300" dirty="0"/>
                     </a:p>
@@ -6479,7 +6479,7 @@
                             <a:schemeClr val="tx2"/>
                           </a:solidFill>
                         </a:rPr>
-                        <a:t>19.211</a:t>
+                        <a:t>20.180</a:t>
                       </a:r>
                       <a:endParaRPr lang="en-US" sz="1300" dirty="0"/>
                     </a:p>
@@ -6597,7 +6597,7 @@
                             <a:schemeClr val="tx2"/>
                           </a:solidFill>
                         </a:rPr>
-                        <a:t>22.469</a:t>
+                        <a:t>23.397</a:t>
                       </a:r>
                       <a:endParaRPr lang="en-US" sz="1300" dirty="0"/>
                     </a:p>
@@ -6715,7 +6715,7 @@
                             <a:schemeClr val="tx2"/>
                           </a:solidFill>
                         </a:rPr>
-                        <a:t>34.967</a:t>
+                        <a:t>35.194</a:t>
                       </a:r>
                       <a:endParaRPr lang="en-US" sz="1300" dirty="0"/>
                     </a:p>
@@ -6833,7 +6833,7 @@
                             <a:schemeClr val="tx2"/>
                           </a:solidFill>
                         </a:rPr>
-                        <a:t>41.681</a:t>
+                        <a:t>41.047</a:t>
                       </a:r>
                       <a:endParaRPr lang="en-US" sz="1300" dirty="0"/>
                     </a:p>
@@ -6912,7 +6912,7 @@
                   <a:schemeClr val="accent6"/>
                 </a:solidFill>
               </a:rPr>
-              <a:t>Software interno: cerca de 1.144 h, ou R$ 119 mil. RFID futuro: + R$ 33 mil e 80 h. Com 10% de contingência e o software, a Arquitetura A soma cerca de R$ 454 mil.</a:t>
+              <a:t>Software interno: cerca de 1.144 h, ou R$ 119 mil. RFID futuro: + R$ 29 mil e 80 h. Com 10% de contingência e o software, a Arquitetura A soma cerca de R$ 477 mil.</a:t>
             </a:r>
             <a:endParaRPr lang="en-US" sz="1200" dirty="0"/>
           </a:p>
@@ -7151,7 +7151,7 @@
                   <a:schemeClr val="accent2"/>
                 </a:solidFill>
               </a:rPr>
-              <a:t>R$ 305 mil</a:t>
+              <a:t>R$ 326 mil</a:t>
             </a:r>
             <a:endParaRPr lang="en-US" sz="3000" dirty="0"/>
           </a:p>
@@ -7412,7 +7412,7 @@
                   <a:schemeClr val="accent3"/>
                 </a:solidFill>
               </a:rPr>
-              <a:t>R$ 335 mil</a:t>
+              <a:t>R$ 342 mil</a:t>
             </a:r>
             <a:endParaRPr lang="en-US" sz="3000" dirty="0"/>
           </a:p>
@@ -7673,7 +7673,7 @@
                   <a:schemeClr val="accent5"/>
                 </a:solidFill>
               </a:rPr>
-              <a:t>R$ 763 mil</a:t>
+              <a:t>R$ 754 mil</a:t>
             </a:r>
             <a:endParaRPr lang="en-US" sz="3000" dirty="0"/>
           </a:p>
@@ -7767,7 +7767,7 @@
                   <a:schemeClr val="tx2"/>
                 </a:solidFill>
               </a:rPr>
-              <a:t>Cerca de 2,5 vezes o custo interno</a:t>
+              <a:t>Cerca de 2,3 vezes o custo interno</a:t>
             </a:r>
             <a:endParaRPr lang="en-US" sz="1400" dirty="0"/>
           </a:p>
@@ -8253,7 +8253,7 @@
                 <a:ea typeface="Arial" pitchFamily="34" charset="-122"/>
                 <a:cs typeface="Arial" pitchFamily="34" charset="-120"/>
               </a:rPr>
-              <a:t>R$ 305 mil</a:t>
+              <a:t>R$ 326 mil</a:t>
             </a:r>
             <a:endParaRPr lang="en-US" sz="3000" dirty="0"/>
           </a:p>
@@ -8391,7 +8391,7 @@
                 <a:ea typeface="Arial" pitchFamily="34" charset="-122"/>
                 <a:cs typeface="Arial" pitchFamily="34" charset="-120"/>
               </a:rPr>
-              <a:t>R$ 22,5 mil</a:t>
+              <a:t>R$ 23,4 mil</a:t>
             </a:r>
             <a:endParaRPr lang="en-US" sz="3000" dirty="0"/>
           </a:p>
@@ -11094,7 +11094,7 @@
                   <a:srgbClr val="C9D3E0"/>
                 </a:solidFill>
               </a:rPr>
-              <a:t>1. Aprovar a POC: bancada + estações 04 e 27 (cerca de R$ 22,5 mil)</a:t>
+              <a:t>1. Aprovar a POC: bancada + estações 04 e 27 (cerca de R$ 23,4 mil)</a:t>
             </a:r>
             <a:endParaRPr lang="en-US" sz="2000" dirty="0"/>
           </a:p>
@@ -13597,7 +13597,7 @@
                   <a:schemeClr val="accent6"/>
                 </a:solidFill>
               </a:rPr>
-              <a:t>Cerca de R$ 130 por unidade, mãos livres. Acréscimo de ~R$ 36 mil para as 40 estações.</a:t>
+              <a:t>Cerca de R$ 113 por unidade, mãos livres. Acréscimo de ~R$ 32 mil para as 40 estações.</a:t>
             </a:r>
             <a:endParaRPr lang="en-US" sz="1300" dirty="0"/>
           </a:p>
@@ -14447,7 +14447,7 @@
                             <a:schemeClr val="tx2"/>
                           </a:solidFill>
                         </a:rPr>
-                        <a:t>R$ 305 mil</a:t>
+                        <a:t>R$ 326 mil</a:t>
                       </a:r>
                       <a:endParaRPr lang="en-US" sz="1500" dirty="0"/>
                     </a:p>
@@ -14505,7 +14505,7 @@
                             <a:schemeClr val="tx2"/>
                           </a:solidFill>
                         </a:rPr>
-                        <a:t>+ R$ 33 mil sobre o coletor</a:t>
+                        <a:t>+ R$ 29 mil sobre o coletor</a:t>
                       </a:r>
                       <a:endParaRPr lang="en-US" sz="1500" dirty="0"/>
                     </a:p>

</xml_diff>

<commit_message>
Carcaças dos LEDs em 3D com valor estipulado; RFID em abas separadas
P13 e P14 voltam a valor estipulado (impressão 3D, medida padrão compacta).
Fontes e peças do RFID futuro ficam em abas próprias, sem misturar com o
projeto. Orçamentos, documento e apresentação regenerados.

Co-Authored-By: Claude Opus 5.5 <noreply@anthropic.com>
Claude-Session: https://claude.ai/code/session_01TBWA3G7ku1j3oTf4VMkLud
</commit_message>
<xml_diff>
--- a/projeto/entregaveis/Apresentacao_PTL.pptx
+++ b/projeto/entregaveis/Apresentacao_PTL.pptx
@@ -129,7 +129,7 @@
   <p:extLst>
     <p:ext uri="{521415D9-36F7-43E2-AB2F-B90AF26B5E84}">
       <p14:sectionLst xmlns:p14="http://schemas.microsoft.com/office/powerpoint/2010/main">
-        <p14:section name="Abertura" id="{27d3931a-97a2-78cc-7020-26a63fa108e4}">
+        <p14:section name="Abertura" id="{bc0ec5f1-db94-7833-f109-df3c812ca87a}">
           <p14:sldIdLst>
             <p14:sldId id="256"/>
             <p14:sldId id="257"/>
@@ -137,7 +137,7 @@
             <p14:sldId id="259"/>
           </p14:sldIdLst>
         </p14:section>
-        <p14:section name="Arquiteturas" id="{a4639e5c-ec6b-2bfb-6c76-d75b7e8bfbcb}">
+        <p14:section name="Arquiteturas" id="{d76b9581-3941-bdc5-3041-d9bc55a280aa}">
           <p14:sldIdLst>
             <p14:sldId id="260"/>
             <p14:sldId id="261"/>
@@ -146,7 +146,7 @@
             <p14:sldId id="264"/>
           </p14:sldIdLst>
         </p14:section>
-        <p14:section name="A estação" id="{2e95718c-474f-e830-d488-f80e8af74993}">
+        <p14:section name="A estação" id="{bd610f43-c7d3-3455-4588-e9ef0a38b815}">
           <p14:sldIdLst>
             <p14:sldId id="265"/>
             <p14:sldId id="266"/>
@@ -157,14 +157,14 @@
             <p14:sldId id="271"/>
           </p14:sldIdLst>
         </p14:section>
-        <p14:section name="Orçamento" id="{93a97ab9-e0b8-85e1-31f0-7c3ee2af3598}">
+        <p14:section name="Orçamento" id="{af852851-8a76-d3fb-bf79-18c3748e1eee}">
           <p14:sldIdLst>
             <p14:sldId id="272"/>
             <p14:sldId id="273"/>
             <p14:sldId id="274"/>
           </p14:sldIdLst>
         </p14:section>
-        <p14:section name="Próximos passos" id="{edb41b84-0f12-70d9-cf50-b28c4553ebb2}">
+        <p14:section name="Próximos passos" id="{4848c3cc-1d8f-6123-cec5-f2c39ee11f9a}">
           <p14:sldIdLst>
             <p14:sldId id="275"/>
             <p14:sldId id="276"/>
@@ -296,13 +296,13 @@
                 <c:formatCode>General</c:formatCode>
                 <c:ptCount val="4"/>
                 <c:pt idx="0">
-                  <c:v>244</c:v>
+                  <c:v>223</c:v>
                 </c:pt>
                 <c:pt idx="1">
-                  <c:v>326</c:v>
+                  <c:v>305</c:v>
                 </c:pt>
                 <c:pt idx="2">
-                  <c:v>342</c:v>
+                  <c:v>328</c:v>
                 </c:pt>
                 <c:pt idx="3">
                   <c:v>754</c:v>
@@ -1731,7 +1731,7 @@
           <a:p>
             <a:r>
               <a:rPr lang="en-US" dirty="0"/>
-              <a:t>Valores com instalação. 12 V × 5 V: o 5 V fica mais caro (R$ 244 mil × R$ 264 mil em materiais), porque a fonte de 5 V e o cabo de força extra custam mais do que os reguladores economizados, e o 5 V ainda aumenta a manutenção. Por isso a indicação é 12 V.</a:t>
+              <a:t>Valores com instalação. 12 V × 5 V: o 5 V fica mais caro (R$ 223 mil × R$ 243 mil em materiais), porque a fonte de 5 V e o cabo de força extra custam mais do que os reguladores economizados, e o 5 V ainda aumenta a manutenção. Por isso a indicação é 12 V.</a:t>
             </a:r>
             <a:endParaRPr lang="en-US" dirty="0"/>
           </a:p>
@@ -6361,7 +6361,7 @@
                             <a:schemeClr val="tx2"/>
                           </a:solidFill>
                         </a:rPr>
-                        <a:t>15.479</a:t>
+                        <a:t>14.434</a:t>
                       </a:r>
                       <a:endParaRPr lang="en-US" sz="1300" dirty="0"/>
                     </a:p>
@@ -6479,7 +6479,7 @@
                             <a:schemeClr val="tx2"/>
                           </a:solidFill>
                         </a:rPr>
-                        <a:t>20.180</a:t>
+                        <a:t>19.135</a:t>
                       </a:r>
                       <a:endParaRPr lang="en-US" sz="1300" dirty="0"/>
                     </a:p>
@@ -6597,7 +6597,7 @@
                             <a:schemeClr val="tx2"/>
                           </a:solidFill>
                         </a:rPr>
-                        <a:t>23.397</a:t>
+                        <a:t>22.244</a:t>
                       </a:r>
                       <a:endParaRPr lang="en-US" sz="1300" dirty="0"/>
                     </a:p>
@@ -6715,7 +6715,7 @@
                             <a:schemeClr val="tx2"/>
                           </a:solidFill>
                         </a:rPr>
-                        <a:t>35.194</a:t>
+                        <a:t>34.489</a:t>
                       </a:r>
                       <a:endParaRPr lang="en-US" sz="1300" dirty="0"/>
                     </a:p>
@@ -6912,7 +6912,7 @@
                   <a:schemeClr val="accent6"/>
                 </a:solidFill>
               </a:rPr>
-              <a:t>Software interno: cerca de 1.144 h, ou R$ 119 mil. RFID futuro: + R$ 29 mil e 80 h. Com 10% de contingência e o software, a Arquitetura A soma cerca de R$ 477 mil.</a:t>
+              <a:t>Software interno: cerca de 1.144 h, ou R$ 119 mil. RFID futuro: + R$ 29 mil e 80 h. Com 10% de contingência e o software, a Arquitetura A soma cerca de R$ 455 mil.</a:t>
             </a:r>
             <a:endParaRPr lang="en-US" sz="1200" dirty="0"/>
           </a:p>
@@ -7151,7 +7151,7 @@
                   <a:schemeClr val="accent2"/>
                 </a:solidFill>
               </a:rPr>
-              <a:t>R$ 326 mil</a:t>
+              <a:t>R$ 305 mil</a:t>
             </a:r>
             <a:endParaRPr lang="en-US" sz="3000" dirty="0"/>
           </a:p>
@@ -7412,7 +7412,7 @@
                   <a:schemeClr val="accent3"/>
                 </a:solidFill>
               </a:rPr>
-              <a:t>R$ 342 mil</a:t>
+              <a:t>R$ 328 mil</a:t>
             </a:r>
             <a:endParaRPr lang="en-US" sz="3000" dirty="0"/>
           </a:p>
@@ -7767,7 +7767,7 @@
                   <a:schemeClr val="tx2"/>
                 </a:solidFill>
               </a:rPr>
-              <a:t>Cerca de 2,3 vezes o custo interno</a:t>
+              <a:t>Cerca de 2,5 vezes o custo interno</a:t>
             </a:r>
             <a:endParaRPr lang="en-US" sz="1400" dirty="0"/>
           </a:p>
@@ -8253,7 +8253,7 @@
                 <a:ea typeface="Arial" pitchFamily="34" charset="-122"/>
                 <a:cs typeface="Arial" pitchFamily="34" charset="-120"/>
               </a:rPr>
-              <a:t>R$ 326 mil</a:t>
+              <a:t>R$ 305 mil</a:t>
             </a:r>
             <a:endParaRPr lang="en-US" sz="3000" dirty="0"/>
           </a:p>
@@ -8391,7 +8391,7 @@
                 <a:ea typeface="Arial" pitchFamily="34" charset="-122"/>
                 <a:cs typeface="Arial" pitchFamily="34" charset="-120"/>
               </a:rPr>
-              <a:t>R$ 23,4 mil</a:t>
+              <a:t>R$ 22,2 mil</a:t>
             </a:r>
             <a:endParaRPr lang="en-US" sz="3000" dirty="0"/>
           </a:p>
@@ -11094,7 +11094,7 @@
                   <a:srgbClr val="C9D3E0"/>
                 </a:solidFill>
               </a:rPr>
-              <a:t>1. Aprovar a POC: bancada + estações 04 e 27 (cerca de R$ 23,4 mil)</a:t>
+              <a:t>1. Aprovar a POC: bancada + estações 04 e 27 (cerca de R$ 22,2 mil)</a:t>
             </a:r>
             <a:endParaRPr lang="en-US" sz="2000" dirty="0"/>
           </a:p>
@@ -14447,7 +14447,7 @@
                             <a:schemeClr val="tx2"/>
                           </a:solidFill>
                         </a:rPr>
-                        <a:t>R$ 326 mil</a:t>
+                        <a:t>R$ 305 mil</a:t>
                       </a:r>
                       <a:endParaRPr lang="en-US" sz="1500" dirty="0"/>
                     </a:p>

</xml_diff>